<commit_message>
docs: finalize submission package and deployment readiness
</commit_message>
<xml_diff>
--- a/slides/bookscope_presentation.pptx
+++ b/slides/bookscope_presentation.pptx
@@ -15,6 +15,9 @@
     <p:sldId id="263" r:id="rId14"/>
     <p:sldId id="264" r:id="rId15"/>
     <p:sldId id="265" r:id="rId16"/>
+    <p:sldId id="266" r:id="rId17"/>
+    <p:sldId id="267" r:id="rId18"/>
+    <p:sldId id="268" r:id="rId19"/>
   </p:sldIdLst>
   <p:sldSz cx="12191695" cy="6858000" type="screen4x3"/>
   <p:notesSz cx="6858000" cy="9144000"/>
@@ -3093,7 +3096,7 @@
     <p:bg>
       <p:bgPr>
         <a:solidFill>
-          <a:srgbClr val="1C294C"/>
+          <a:srgbClr val="1E2761"/>
         </a:solidFill>
         <a:effectLst/>
       </p:bgPr>
@@ -3113,8 +3116,8 @@
         </p:nvSpPr>
         <p:spPr>
           <a:xfrm>
-            <a:off x="731520" y="548640"/>
-            <a:ext cx="10607040" cy="822960"/>
+            <a:off x="640080" y="411480"/>
+            <a:ext cx="8412480" cy="640080"/>
           </a:xfrm>
           <a:prstGeom prst="rect">
             <a:avLst/>
@@ -3122,13 +3125,13 @@
           <a:noFill/>
         </p:spPr>
         <p:txBody>
-          <a:bodyPr wrap="square">
+          <a:bodyPr wrap="square" anchor="t" lIns="0" rIns="0" tIns="0" bIns="0">
             <a:spAutoFit/>
           </a:bodyPr>
           <a:lstStyle/>
           <a:p>
-            <a:pPr>
-              <a:defRPr sz="3000" b="1">
+            <a:pPr algn="l">
+              <a:defRPr sz="2800" b="1">
                 <a:solidFill>
                   <a:srgbClr val="FFFFFF"/>
                 </a:solidFill>
@@ -3148,8 +3151,8 @@
         </p:nvSpPr>
         <p:spPr>
           <a:xfrm>
-            <a:off x="731520" y="1554480"/>
-            <a:ext cx="1188720" cy="128016"/>
+            <a:off x="640080" y="1188720"/>
+            <a:ext cx="1325880" cy="109728"/>
           </a:xfrm>
           <a:prstGeom prst="rect">
             <a:avLst/>
@@ -3191,8 +3194,8 @@
         </p:nvSpPr>
         <p:spPr>
           <a:xfrm>
-            <a:off x="868680" y="1874519"/>
-            <a:ext cx="10332720" cy="3566160"/>
+            <a:off x="10881360" y="384048"/>
+            <a:ext cx="548640" cy="274320"/>
           </a:xfrm>
           <a:prstGeom prst="rect">
             <a:avLst/>
@@ -3200,20 +3203,20 @@
           <a:noFill/>
         </p:spPr>
         <p:txBody>
-          <a:bodyPr wrap="square" lIns="0" rIns="0" tIns="0" bIns="0">
+          <a:bodyPr wrap="square" anchor="t" lIns="0" rIns="0" tIns="0" bIns="0">
             <a:spAutoFit/>
           </a:bodyPr>
           <a:lstStyle/>
           <a:p>
-            <a:pPr algn="l">
-              <a:defRPr sz="2000">
+            <a:pPr algn="r">
+              <a:defRPr sz="1000" b="0">
                 <a:solidFill>
                   <a:srgbClr val="FFFFFF"/>
                 </a:solidFill>
               </a:defRPr>
             </a:pPr>
             <a:r>
-              <a:t>Google Books ingestion, local catalog ownership, personal bookshelf workflows, explainable recommendations, and reading analytics.</a:t>
+              <a:t>01</a:t>
             </a:r>
           </a:p>
         </p:txBody>
@@ -3226,8 +3229,8 @@
         </p:nvSpPr>
         <p:spPr>
           <a:xfrm>
-            <a:off x="9966960" y="6217920"/>
-            <a:ext cx="1005840" cy="274320"/>
+            <a:off x="685800" y="1737360"/>
+            <a:ext cx="6858000" cy="1280160"/>
           </a:xfrm>
           <a:prstGeom prst="rect">
             <a:avLst/>
@@ -3235,20 +3238,133 @@
           <a:noFill/>
         </p:spPr>
         <p:txBody>
-          <a:bodyPr wrap="none">
+          <a:bodyPr wrap="square" anchor="t" lIns="0" rIns="0" tIns="0" bIns="0">
             <a:spAutoFit/>
           </a:bodyPr>
           <a:lstStyle/>
           <a:p>
-            <a:pPr algn="r">
-              <a:defRPr sz="1000">
+            <a:pPr algn="l">
+              <a:defRPr sz="2400" b="0">
                 <a:solidFill>
                   <a:srgbClr val="FFFFFF"/>
                 </a:solidFill>
               </a:defRPr>
             </a:pPr>
             <a:r>
-              <a:t>01</a:t>
+              <a:t>Google Books ingestion, local catalog ownership, personal bookshelf workflows, explainable recommendations, and reading analytics.</a:t>
+            </a:r>
+          </a:p>
+        </p:txBody>
+      </p:sp>
+      <p:sp>
+        <p:nvSpPr>
+          <p:cNvPr id="6" name="Rounded Rectangle 5"/>
+          <p:cNvSpPr/>
+          <p:nvPr/>
+        </p:nvSpPr>
+        <p:spPr>
+          <a:xfrm>
+            <a:off x="7955279" y="1691640"/>
+            <a:ext cx="3383280" cy="1143000"/>
+          </a:xfrm>
+          <a:prstGeom prst="roundRect">
+            <a:avLst/>
+          </a:prstGeom>
+          <a:solidFill>
+            <a:srgbClr val="344380"/>
+          </a:solidFill>
+          <a:ln>
+            <a:solidFill>
+              <a:srgbClr val="344380"/>
+            </a:solidFill>
+          </a:ln>
+        </p:spPr>
+        <p:style>
+          <a:lnRef idx="1">
+            <a:schemeClr val="accent1"/>
+          </a:lnRef>
+          <a:fillRef idx="3">
+            <a:schemeClr val="accent1"/>
+          </a:fillRef>
+          <a:effectRef idx="2">
+            <a:schemeClr val="accent1"/>
+          </a:effectRef>
+          <a:fontRef idx="minor">
+            <a:schemeClr val="lt1"/>
+          </a:fontRef>
+        </p:style>
+        <p:txBody>
+          <a:bodyPr rtlCol="0" anchor="ctr" wrap="square" lIns="164592" rIns="164592" tIns="128016" bIns="109728"/>
+          <a:lstStyle/>
+          <a:p>
+            <a:pPr algn="ctr">
+              <a:defRPr sz="1600" b="1">
+                <a:solidFill>
+                  <a:srgbClr val="FFFFFF"/>
+                </a:solidFill>
+              </a:defRPr>
+            </a:pPr>
+            <a:r>
+              <a:t>Stack</a:t>
+            </a:r>
+          </a:p>
+          <a:p>
+            <a:pPr>
+              <a:defRPr sz="1200">
+                <a:solidFill>
+                  <a:srgbClr val="FFFFFF"/>
+                </a:solidFill>
+              </a:defRPr>
+            </a:pPr>
+            <a:r>
+              <a:t>Django REST Framework</a:t>
+            </a:r>
+            <a:br/>
+            <a:r>
+              <a:t>SQLite</a:t>
+            </a:r>
+            <a:br/>
+            <a:r>
+              <a:t>Simple JWT</a:t>
+            </a:r>
+            <a:br/>
+            <a:r>
+              <a:t>OpenAPI</a:t>
+            </a:r>
+          </a:p>
+        </p:txBody>
+      </p:sp>
+      <p:sp>
+        <p:nvSpPr>
+          <p:cNvPr id="7" name="TextBox 6"/>
+          <p:cNvSpPr txBox="1"/>
+          <p:nvPr/>
+        </p:nvSpPr>
+        <p:spPr>
+          <a:xfrm>
+            <a:off x="685800" y="5897880"/>
+            <a:ext cx="7132320" cy="320040"/>
+          </a:xfrm>
+          <a:prstGeom prst="rect">
+            <a:avLst/>
+          </a:prstGeom>
+          <a:noFill/>
+        </p:spPr>
+        <p:txBody>
+          <a:bodyPr wrap="square" anchor="t" lIns="0" rIns="0" tIns="0" bIns="0">
+            <a:spAutoFit/>
+          </a:bodyPr>
+          <a:lstStyle/>
+          <a:p>
+            <a:pPr algn="l">
+              <a:defRPr sz="1100" b="0">
+                <a:solidFill>
+                  <a:srgbClr val="FFFFFF"/>
+                </a:solidFill>
+              </a:defRPr>
+            </a:pPr>
+            <a:r>
+              <a:t>Repository: github.com/IJF9GAWHY8FGA8/bookscope-api</a:t>
             </a:r>
           </a:p>
         </p:txBody>
@@ -3267,7 +3383,7 @@
     <p:bg>
       <p:bgPr>
         <a:solidFill>
-          <a:srgbClr val="1C294C"/>
+          <a:srgbClr val="F7F4EA"/>
         </a:solidFill>
         <a:effectLst/>
       </p:bgPr>
@@ -3287,8 +3403,8 @@
         </p:nvSpPr>
         <p:spPr>
           <a:xfrm>
-            <a:off x="731520" y="548640"/>
-            <a:ext cx="10607040" cy="822960"/>
+            <a:off x="640080" y="411480"/>
+            <a:ext cx="8412480" cy="640080"/>
           </a:xfrm>
           <a:prstGeom prst="rect">
             <a:avLst/>
@@ -3296,20 +3412,20 @@
           <a:noFill/>
         </p:spPr>
         <p:txBody>
-          <a:bodyPr wrap="square">
+          <a:bodyPr wrap="square" anchor="t" lIns="0" rIns="0" tIns="0" bIns="0">
             <a:spAutoFit/>
           </a:bodyPr>
           <a:lstStyle/>
           <a:p>
-            <a:pPr>
+            <a:pPr algn="l">
               <a:defRPr sz="2800" b="1">
                 <a:solidFill>
-                  <a:srgbClr val="FFFFFF"/>
-                </a:solidFill>
-              </a:defRPr>
-            </a:pPr>
-            <a:r>
-              <a:t>Limitations and Next Steps</a:t>
+                  <a:srgbClr val="272C34"/>
+                </a:solidFill>
+              </a:defRPr>
+            </a:pPr>
+            <a:r>
+              <a:t>Deliverables and Deployment</a:t>
             </a:r>
           </a:p>
         </p:txBody>
@@ -3322,8 +3438,482 @@
         </p:nvSpPr>
         <p:spPr>
           <a:xfrm>
-            <a:off x="731520" y="1554480"/>
-            <a:ext cx="1188720" cy="128016"/>
+            <a:off x="640080" y="1188720"/>
+            <a:ext cx="1325880" cy="109728"/>
+          </a:xfrm>
+          <a:prstGeom prst="rect">
+            <a:avLst/>
+          </a:prstGeom>
+          <a:solidFill>
+            <a:srgbClr val="F96167"/>
+          </a:solidFill>
+          <a:ln>
+            <a:noFill/>
+          </a:ln>
+        </p:spPr>
+        <p:style>
+          <a:lnRef idx="1">
+            <a:schemeClr val="accent1"/>
+          </a:lnRef>
+          <a:fillRef idx="3">
+            <a:schemeClr val="accent1"/>
+          </a:fillRef>
+          <a:effectRef idx="2">
+            <a:schemeClr val="accent1"/>
+          </a:effectRef>
+          <a:fontRef idx="minor">
+            <a:schemeClr val="lt1"/>
+          </a:fontRef>
+        </p:style>
+        <p:txBody>
+          <a:bodyPr rtlCol="0" anchor="ctr"/>
+          <a:lstStyle/>
+          <a:p>
+            <a:pPr algn="ctr"/>
+          </a:p>
+        </p:txBody>
+      </p:sp>
+      <p:sp>
+        <p:nvSpPr>
+          <p:cNvPr id="4" name="TextBox 3"/>
+          <p:cNvSpPr txBox="1"/>
+          <p:nvPr/>
+        </p:nvSpPr>
+        <p:spPr>
+          <a:xfrm>
+            <a:off x="10881360" y="384048"/>
+            <a:ext cx="548640" cy="274320"/>
+          </a:xfrm>
+          <a:prstGeom prst="rect">
+            <a:avLst/>
+          </a:prstGeom>
+          <a:noFill/>
+        </p:spPr>
+        <p:txBody>
+          <a:bodyPr wrap="square" anchor="t" lIns="0" rIns="0" tIns="0" bIns="0">
+            <a:spAutoFit/>
+          </a:bodyPr>
+          <a:lstStyle/>
+          <a:p>
+            <a:pPr algn="r">
+              <a:defRPr sz="1000" b="0">
+                <a:solidFill>
+                  <a:srgbClr val="272C34"/>
+                </a:solidFill>
+              </a:defRPr>
+            </a:pPr>
+            <a:r>
+              <a:t>10</a:t>
+            </a:r>
+          </a:p>
+        </p:txBody>
+      </p:sp>
+      <p:sp>
+        <p:nvSpPr>
+          <p:cNvPr id="5" name="Rounded Rectangle 4"/>
+          <p:cNvSpPr/>
+          <p:nvPr/>
+        </p:nvSpPr>
+        <p:spPr>
+          <a:xfrm>
+            <a:off x="868680" y="1737360"/>
+            <a:ext cx="2468880" cy="1554480"/>
+          </a:xfrm>
+          <a:prstGeom prst="roundRect">
+            <a:avLst/>
+          </a:prstGeom>
+          <a:solidFill>
+            <a:srgbClr val="FFFFFF"/>
+          </a:solidFill>
+          <a:ln>
+            <a:solidFill>
+              <a:srgbClr val="FFFFFF"/>
+            </a:solidFill>
+          </a:ln>
+        </p:spPr>
+        <p:style>
+          <a:lnRef idx="1">
+            <a:schemeClr val="accent1"/>
+          </a:lnRef>
+          <a:fillRef idx="3">
+            <a:schemeClr val="accent1"/>
+          </a:fillRef>
+          <a:effectRef idx="2">
+            <a:schemeClr val="accent1"/>
+          </a:effectRef>
+          <a:fontRef idx="minor">
+            <a:schemeClr val="lt1"/>
+          </a:fontRef>
+        </p:style>
+        <p:txBody>
+          <a:bodyPr rtlCol="0" anchor="ctr" wrap="square" lIns="164592" rIns="164592" tIns="128016" bIns="109728"/>
+          <a:lstStyle/>
+          <a:p>
+            <a:pPr algn="ctr">
+              <a:defRPr sz="1600" b="1">
+                <a:solidFill>
+                  <a:srgbClr val="1E2761"/>
+                </a:solidFill>
+              </a:defRPr>
+            </a:pPr>
+            <a:r>
+              <a:t>Deliverables</a:t>
+            </a:r>
+          </a:p>
+          <a:p>
+            <a:pPr>
+              <a:defRPr sz="1200">
+                <a:solidFill>
+                  <a:srgbClr val="272C34"/>
+                </a:solidFill>
+              </a:defRPr>
+            </a:pPr>
+            <a:r>
+              <a:t>Public repo</a:t>
+            </a:r>
+            <a:br/>
+            <a:r>
+              <a:t>README</a:t>
+            </a:r>
+            <a:br/>
+            <a:r>
+              <a:t>API docs PDF</a:t>
+            </a:r>
+            <a:br/>
+            <a:r>
+              <a:t>Technical report PDF</a:t>
+            </a:r>
+          </a:p>
+        </p:txBody>
+      </p:sp>
+      <p:sp>
+        <p:nvSpPr>
+          <p:cNvPr id="6" name="Rounded Rectangle 5"/>
+          <p:cNvSpPr/>
+          <p:nvPr/>
+        </p:nvSpPr>
+        <p:spPr>
+          <a:xfrm>
+            <a:off x="3611880" y="1737360"/>
+            <a:ext cx="2468880" cy="1554480"/>
+          </a:xfrm>
+          <a:prstGeom prst="roundRect">
+            <a:avLst/>
+          </a:prstGeom>
+          <a:solidFill>
+            <a:srgbClr val="FFFFFF"/>
+          </a:solidFill>
+          <a:ln>
+            <a:solidFill>
+              <a:srgbClr val="FFFFFF"/>
+            </a:solidFill>
+          </a:ln>
+        </p:spPr>
+        <p:style>
+          <a:lnRef idx="1">
+            <a:schemeClr val="accent1"/>
+          </a:lnRef>
+          <a:fillRef idx="3">
+            <a:schemeClr val="accent1"/>
+          </a:fillRef>
+          <a:effectRef idx="2">
+            <a:schemeClr val="accent1"/>
+          </a:effectRef>
+          <a:fontRef idx="minor">
+            <a:schemeClr val="lt1"/>
+          </a:fontRef>
+        </p:style>
+        <p:txBody>
+          <a:bodyPr rtlCol="0" anchor="ctr" wrap="square" lIns="164592" rIns="164592" tIns="128016" bIns="109728"/>
+          <a:lstStyle/>
+          <a:p>
+            <a:pPr algn="ctr">
+              <a:defRPr sz="1600" b="1">
+                <a:solidFill>
+                  <a:srgbClr val="1E2761"/>
+                </a:solidFill>
+              </a:defRPr>
+            </a:pPr>
+            <a:r>
+              <a:t>More deliverables</a:t>
+            </a:r>
+          </a:p>
+          <a:p>
+            <a:pPr>
+              <a:defRPr sz="1200">
+                <a:solidFill>
+                  <a:srgbClr val="272C34"/>
+                </a:solidFill>
+              </a:defRPr>
+            </a:pPr>
+            <a:r>
+              <a:t>GenAI appendix</a:t>
+            </a:r>
+            <a:br/>
+            <a:r>
+              <a:t>Conversation logs appendix</a:t>
+            </a:r>
+            <a:br/>
+            <a:r>
+              <a:t>Slides PPTX</a:t>
+            </a:r>
+            <a:br/>
+            <a:r>
+              <a:t>Tests</a:t>
+            </a:r>
+          </a:p>
+        </p:txBody>
+      </p:sp>
+      <p:sp>
+        <p:nvSpPr>
+          <p:cNvPr id="7" name="Rounded Rectangle 6"/>
+          <p:cNvSpPr/>
+          <p:nvPr/>
+        </p:nvSpPr>
+        <p:spPr>
+          <a:xfrm>
+            <a:off x="6355080" y="1737360"/>
+            <a:ext cx="2468880" cy="1554480"/>
+          </a:xfrm>
+          <a:prstGeom prst="roundRect">
+            <a:avLst/>
+          </a:prstGeom>
+          <a:solidFill>
+            <a:srgbClr val="FFFFFF"/>
+          </a:solidFill>
+          <a:ln>
+            <a:solidFill>
+              <a:srgbClr val="FFFFFF"/>
+            </a:solidFill>
+          </a:ln>
+        </p:spPr>
+        <p:style>
+          <a:lnRef idx="1">
+            <a:schemeClr val="accent1"/>
+          </a:lnRef>
+          <a:fillRef idx="3">
+            <a:schemeClr val="accent1"/>
+          </a:fillRef>
+          <a:effectRef idx="2">
+            <a:schemeClr val="accent1"/>
+          </a:effectRef>
+          <a:fontRef idx="minor">
+            <a:schemeClr val="lt1"/>
+          </a:fontRef>
+        </p:style>
+        <p:txBody>
+          <a:bodyPr rtlCol="0" anchor="ctr" wrap="square" lIns="164592" rIns="164592" tIns="128016" bIns="109728"/>
+          <a:lstStyle/>
+          <a:p>
+            <a:pPr algn="ctr">
+              <a:defRPr sz="1600" b="1">
+                <a:solidFill>
+                  <a:srgbClr val="1E2761"/>
+                </a:solidFill>
+              </a:defRPr>
+            </a:pPr>
+            <a:r>
+              <a:t>Deployment package</a:t>
+            </a:r>
+          </a:p>
+          <a:p>
+            <a:pPr>
+              <a:defRPr sz="1200">
+                <a:solidFill>
+                  <a:srgbClr val="272C34"/>
+                </a:solidFill>
+              </a:defRPr>
+            </a:pPr>
+            <a:r>
+              <a:t>Procfile</a:t>
+            </a:r>
+            <a:br/>
+            <a:r>
+              <a:t>render.yaml</a:t>
+            </a:r>
+            <a:br/>
+            <a:r>
+              <a:t>gunicorn</a:t>
+            </a:r>
+            <a:br/>
+            <a:r>
+              <a:t>Env-driven hosts and secrets</a:t>
+            </a:r>
+          </a:p>
+        </p:txBody>
+      </p:sp>
+      <p:sp>
+        <p:nvSpPr>
+          <p:cNvPr id="8" name="Rounded Rectangle 7"/>
+          <p:cNvSpPr/>
+          <p:nvPr/>
+        </p:nvSpPr>
+        <p:spPr>
+          <a:xfrm>
+            <a:off x="9098280" y="1737360"/>
+            <a:ext cx="2148840" cy="1554480"/>
+          </a:xfrm>
+          <a:prstGeom prst="roundRect">
+            <a:avLst/>
+          </a:prstGeom>
+          <a:solidFill>
+            <a:srgbClr val="E7E8D1"/>
+          </a:solidFill>
+          <a:ln>
+            <a:solidFill>
+              <a:srgbClr val="E7E8D1"/>
+            </a:solidFill>
+          </a:ln>
+        </p:spPr>
+        <p:style>
+          <a:lnRef idx="1">
+            <a:schemeClr val="accent1"/>
+          </a:lnRef>
+          <a:fillRef idx="3">
+            <a:schemeClr val="accent1"/>
+          </a:fillRef>
+          <a:effectRef idx="2">
+            <a:schemeClr val="accent1"/>
+          </a:effectRef>
+          <a:fontRef idx="minor">
+            <a:schemeClr val="lt1"/>
+          </a:fontRef>
+        </p:style>
+        <p:txBody>
+          <a:bodyPr rtlCol="0" anchor="ctr" wrap="square" lIns="164592" rIns="164592" tIns="128016" bIns="109728"/>
+          <a:lstStyle/>
+          <a:p>
+            <a:pPr algn="ctr">
+              <a:defRPr sz="1600" b="1">
+                <a:solidFill>
+                  <a:srgbClr val="1E2761"/>
+                </a:solidFill>
+              </a:defRPr>
+            </a:pPr>
+            <a:r>
+              <a:t>Hosting note</a:t>
+            </a:r>
+          </a:p>
+          <a:p>
+            <a:pPr>
+              <a:defRPr sz="1200">
+                <a:solidFill>
+                  <a:srgbClr val="272C34"/>
+                </a:solidFill>
+              </a:defRPr>
+            </a:pPr>
+            <a:r>
+              <a:t>Provisioning needs a real hosting account. This repo is prepared for that step.</a:t>
+            </a:r>
+          </a:p>
+        </p:txBody>
+      </p:sp>
+      <p:sp>
+        <p:nvSpPr>
+          <p:cNvPr id="9" name="TextBox 8"/>
+          <p:cNvSpPr txBox="1"/>
+          <p:nvPr/>
+        </p:nvSpPr>
+        <p:spPr>
+          <a:xfrm>
+            <a:off x="868680" y="3977639"/>
+            <a:ext cx="10149840" cy="1005840"/>
+          </a:xfrm>
+          <a:prstGeom prst="rect">
+            <a:avLst/>
+          </a:prstGeom>
+          <a:noFill/>
+        </p:spPr>
+        <p:txBody>
+          <a:bodyPr wrap="square" anchor="t" lIns="0" rIns="0" tIns="0" bIns="0">
+            <a:spAutoFit/>
+          </a:bodyPr>
+          <a:lstStyle/>
+          <a:p>
+            <a:pPr algn="l">
+              <a:defRPr sz="1700" b="0">
+                <a:solidFill>
+                  <a:srgbClr val="272C34"/>
+                </a:solidFill>
+              </a:defRPr>
+            </a:pPr>
+            <a:r>
+              <a:t>Repository URL: github.com/IJF9GAWHY8FGA8/bookscope-api</a:t>
+            </a:r>
+          </a:p>
+        </p:txBody>
+      </p:sp>
+    </p:spTree>
+  </p:cSld>
+  <p:clrMapOvr>
+    <a:masterClrMapping/>
+  </p:clrMapOvr>
+</p:sld>
+</file>
+
+<file path=ppt/slides/slide11.xml><?xml version="1.0" encoding="utf-8"?>
+<p:sld xmlns:a="http://schemas.openxmlformats.org/drawingml/2006/main" xmlns:p="http://schemas.openxmlformats.org/presentationml/2006/main" xmlns:r="http://schemas.openxmlformats.org/officeDocument/2006/relationships">
+  <p:cSld>
+    <p:bg>
+      <p:bgPr>
+        <a:solidFill>
+          <a:srgbClr val="F7F4EA"/>
+        </a:solidFill>
+        <a:effectLst/>
+      </p:bgPr>
+    </p:bg>
+    <p:spTree>
+      <p:nvGrpSpPr>
+        <p:cNvPr id="1" name=""/>
+        <p:cNvGrpSpPr/>
+        <p:nvPr/>
+      </p:nvGrpSpPr>
+      <p:grpSpPr/>
+      <p:sp>
+        <p:nvSpPr>
+          <p:cNvPr id="2" name="TextBox 1"/>
+          <p:cNvSpPr txBox="1"/>
+          <p:nvPr/>
+        </p:nvSpPr>
+        <p:spPr>
+          <a:xfrm>
+            <a:off x="640080" y="411480"/>
+            <a:ext cx="8412480" cy="640080"/>
+          </a:xfrm>
+          <a:prstGeom prst="rect">
+            <a:avLst/>
+          </a:prstGeom>
+          <a:noFill/>
+        </p:spPr>
+        <p:txBody>
+          <a:bodyPr wrap="square" anchor="t" lIns="0" rIns="0" tIns="0" bIns="0">
+            <a:spAutoFit/>
+          </a:bodyPr>
+          <a:lstStyle/>
+          <a:p>
+            <a:pPr algn="l">
+              <a:defRPr sz="2800" b="1">
+                <a:solidFill>
+                  <a:srgbClr val="272C34"/>
+                </a:solidFill>
+              </a:defRPr>
+            </a:pPr>
+            <a:r>
+              <a:t>Technical Report Highlights</a:t>
+            </a:r>
+          </a:p>
+        </p:txBody>
+      </p:sp>
+      <p:sp>
+        <p:nvSpPr>
+          <p:cNvPr id="3" name="Rectangle 2"/>
+          <p:cNvSpPr/>
+          <p:nvPr/>
+        </p:nvSpPr>
+        <p:spPr>
+          <a:xfrm>
+            <a:off x="640080" y="1188720"/>
+            <a:ext cx="1325880" cy="109728"/>
           </a:xfrm>
           <a:prstGeom prst="rect">
             <a:avLst/>
@@ -3365,8 +3955,43 @@
         </p:nvSpPr>
         <p:spPr>
           <a:xfrm>
-            <a:off x="868680" y="1874519"/>
-            <a:ext cx="10332720" cy="3566160"/>
+            <a:off x="10881360" y="384048"/>
+            <a:ext cx="548640" cy="274320"/>
+          </a:xfrm>
+          <a:prstGeom prst="rect">
+            <a:avLst/>
+          </a:prstGeom>
+          <a:noFill/>
+        </p:spPr>
+        <p:txBody>
+          <a:bodyPr wrap="square" anchor="t" lIns="0" rIns="0" tIns="0" bIns="0">
+            <a:spAutoFit/>
+          </a:bodyPr>
+          <a:lstStyle/>
+          <a:p>
+            <a:pPr algn="r">
+              <a:defRPr sz="1000" b="0">
+                <a:solidFill>
+                  <a:srgbClr val="272C34"/>
+                </a:solidFill>
+              </a:defRPr>
+            </a:pPr>
+            <a:r>
+              <a:t>11</a:t>
+            </a:r>
+          </a:p>
+        </p:txBody>
+      </p:sp>
+      <p:sp>
+        <p:nvSpPr>
+          <p:cNvPr id="5" name="TextBox 4"/>
+          <p:cNvSpPr txBox="1"/>
+          <p:nvPr/>
+        </p:nvSpPr>
+        <p:spPr>
+          <a:xfrm>
+            <a:off x="868680" y="1783080"/>
+            <a:ext cx="5303520" cy="3566160"/>
           </a:xfrm>
           <a:prstGeom prst="rect">
             <a:avLst/>
@@ -3379,15 +4004,637 @@
           </a:bodyPr>
           <a:lstStyle/>
           <a:p>
+            <a:pPr>
+              <a:defRPr sz="1700">
+                <a:solidFill>
+                  <a:srgbClr val="272C34"/>
+                </a:solidFill>
+              </a:defRPr>
+            </a:pPr>
+            <a:r>
+              <a:t>Why Django, DRF, and SQLite were selected</a:t>
+            </a:r>
+          </a:p>
+          <a:p>
+            <a:pPr>
+              <a:defRPr sz="1700">
+                <a:solidFill>
+                  <a:srgbClr val="272C34"/>
+                </a:solidFill>
+              </a:defRPr>
+            </a:pPr>
+            <a:r>
+              <a:t>Why Google Books is treated as an external metadata source, not a runtime backend</a:t>
+            </a:r>
+          </a:p>
+          <a:p>
+            <a:pPr>
+              <a:defRPr sz="1700">
+                <a:solidFill>
+                  <a:srgbClr val="272C34"/>
+                </a:solidFill>
+              </a:defRPr>
+            </a:pPr>
+            <a:r>
+              <a:t>Why rule-based recommendation is easier to justify and test in this coursework</a:t>
+            </a:r>
+          </a:p>
+          <a:p>
+            <a:pPr>
+              <a:defRPr sz="1700">
+                <a:solidFill>
+                  <a:srgbClr val="272C34"/>
+                </a:solidFill>
+              </a:defRPr>
+            </a:pPr>
+            <a:r>
+              <a:t>Where the main limitations and future improvements sit</a:t>
+            </a:r>
+          </a:p>
+        </p:txBody>
+      </p:sp>
+      <p:sp>
+        <p:nvSpPr>
+          <p:cNvPr id="6" name="Rounded Rectangle 5"/>
+          <p:cNvSpPr/>
+          <p:nvPr/>
+        </p:nvSpPr>
+        <p:spPr>
+          <a:xfrm>
+            <a:off x="6400800" y="1783080"/>
+            <a:ext cx="4754880" cy="2011680"/>
+          </a:xfrm>
+          <a:prstGeom prst="roundRect">
+            <a:avLst/>
+          </a:prstGeom>
+          <a:solidFill>
+            <a:srgbClr val="FFFFFF"/>
+          </a:solidFill>
+          <a:ln>
+            <a:solidFill>
+              <a:srgbClr val="FFFFFF"/>
+            </a:solidFill>
+          </a:ln>
+        </p:spPr>
+        <p:style>
+          <a:lnRef idx="1">
+            <a:schemeClr val="accent1"/>
+          </a:lnRef>
+          <a:fillRef idx="3">
+            <a:schemeClr val="accent1"/>
+          </a:fillRef>
+          <a:effectRef idx="2">
+            <a:schemeClr val="accent1"/>
+          </a:effectRef>
+          <a:fontRef idx="minor">
+            <a:schemeClr val="lt1"/>
+          </a:fontRef>
+        </p:style>
+        <p:txBody>
+          <a:bodyPr rtlCol="0" anchor="ctr" wrap="square" lIns="164592" rIns="164592" tIns="128016" bIns="109728"/>
+          <a:lstStyle/>
+          <a:p>
+            <a:pPr algn="ctr">
+              <a:defRPr sz="1600" b="1">
+                <a:solidFill>
+                  <a:srgbClr val="1E2761"/>
+                </a:solidFill>
+              </a:defRPr>
+            </a:pPr>
+            <a:r>
+              <a:t>Submission links inside the report</a:t>
+            </a:r>
+          </a:p>
+          <a:p>
+            <a:pPr>
+              <a:defRPr sz="1200">
+                <a:solidFill>
+                  <a:srgbClr val="272C34"/>
+                </a:solidFill>
+              </a:defRPr>
+            </a:pPr>
+            <a:r>
+              <a:t>Repository link</a:t>
+            </a:r>
+            <a:br/>
+            <a:r>
+              <a:t>API docs link</a:t>
+            </a:r>
+            <a:br/>
+            <a:r>
+              <a:t>Slides link</a:t>
+            </a:r>
+            <a:br/>
+            <a:r>
+              <a:t>GenAI appendix link</a:t>
+            </a:r>
+            <a:br/>
+            <a:r>
+              <a:t>Conversation logs appendix link</a:t>
+            </a:r>
+          </a:p>
+        </p:txBody>
+      </p:sp>
+      <p:sp>
+        <p:nvSpPr>
+          <p:cNvPr id="7" name="TextBox 6"/>
+          <p:cNvSpPr txBox="1"/>
+          <p:nvPr/>
+        </p:nvSpPr>
+        <p:spPr>
+          <a:xfrm>
+            <a:off x="868680" y="4297680"/>
+            <a:ext cx="10058400" cy="914400"/>
+          </a:xfrm>
+          <a:prstGeom prst="rect">
+            <a:avLst/>
+          </a:prstGeom>
+          <a:noFill/>
+        </p:spPr>
+        <p:txBody>
+          <a:bodyPr wrap="square" anchor="t" lIns="0" rIns="0" tIns="0" bIns="0">
+            <a:spAutoFit/>
+          </a:bodyPr>
+          <a:lstStyle/>
+          <a:p>
             <a:pPr algn="l">
-              <a:defRPr sz="2000">
+              <a:defRPr sz="1800" b="0">
+                <a:solidFill>
+                  <a:srgbClr val="272C34"/>
+                </a:solidFill>
+              </a:defRPr>
+            </a:pPr>
+            <a:r>
+              <a:t>The report stays within the five-page body limit while still covering architecture, testing, tradeoffs, limitations, and references.</a:t>
+            </a:r>
+          </a:p>
+        </p:txBody>
+      </p:sp>
+    </p:spTree>
+  </p:cSld>
+  <p:clrMapOvr>
+    <a:masterClrMapping/>
+  </p:clrMapOvr>
+</p:sld>
+</file>
+
+<file path=ppt/slides/slide12.xml><?xml version="1.0" encoding="utf-8"?>
+<p:sld xmlns:a="http://schemas.openxmlformats.org/drawingml/2006/main" xmlns:p="http://schemas.openxmlformats.org/presentationml/2006/main" xmlns:r="http://schemas.openxmlformats.org/officeDocument/2006/relationships">
+  <p:cSld>
+    <p:bg>
+      <p:bgPr>
+        <a:solidFill>
+          <a:srgbClr val="F7F4EA"/>
+        </a:solidFill>
+        <a:effectLst/>
+      </p:bgPr>
+    </p:bg>
+    <p:spTree>
+      <p:nvGrpSpPr>
+        <p:cNvPr id="1" name=""/>
+        <p:cNvGrpSpPr/>
+        <p:nvPr/>
+      </p:nvGrpSpPr>
+      <p:grpSpPr/>
+      <p:sp>
+        <p:nvSpPr>
+          <p:cNvPr id="2" name="TextBox 1"/>
+          <p:cNvSpPr txBox="1"/>
+          <p:nvPr/>
+        </p:nvSpPr>
+        <p:spPr>
+          <a:xfrm>
+            <a:off x="640080" y="411480"/>
+            <a:ext cx="8412480" cy="640080"/>
+          </a:xfrm>
+          <a:prstGeom prst="rect">
+            <a:avLst/>
+          </a:prstGeom>
+          <a:noFill/>
+        </p:spPr>
+        <p:txBody>
+          <a:bodyPr wrap="square" anchor="t" lIns="0" rIns="0" tIns="0" bIns="0">
+            <a:spAutoFit/>
+          </a:bodyPr>
+          <a:lstStyle/>
+          <a:p>
+            <a:pPr algn="l">
+              <a:defRPr sz="2800" b="1">
+                <a:solidFill>
+                  <a:srgbClr val="272C34"/>
+                </a:solidFill>
+              </a:defRPr>
+            </a:pPr>
+            <a:r>
+              <a:t>GenAI Usage and Oversight</a:t>
+            </a:r>
+          </a:p>
+        </p:txBody>
+      </p:sp>
+      <p:sp>
+        <p:nvSpPr>
+          <p:cNvPr id="3" name="Rectangle 2"/>
+          <p:cNvSpPr/>
+          <p:nvPr/>
+        </p:nvSpPr>
+        <p:spPr>
+          <a:xfrm>
+            <a:off x="640080" y="1188720"/>
+            <a:ext cx="1325880" cy="109728"/>
+          </a:xfrm>
+          <a:prstGeom prst="rect">
+            <a:avLst/>
+          </a:prstGeom>
+          <a:solidFill>
+            <a:srgbClr val="F96167"/>
+          </a:solidFill>
+          <a:ln>
+            <a:noFill/>
+          </a:ln>
+        </p:spPr>
+        <p:style>
+          <a:lnRef idx="1">
+            <a:schemeClr val="accent1"/>
+          </a:lnRef>
+          <a:fillRef idx="3">
+            <a:schemeClr val="accent1"/>
+          </a:fillRef>
+          <a:effectRef idx="2">
+            <a:schemeClr val="accent1"/>
+          </a:effectRef>
+          <a:fontRef idx="minor">
+            <a:schemeClr val="lt1"/>
+          </a:fontRef>
+        </p:style>
+        <p:txBody>
+          <a:bodyPr rtlCol="0" anchor="ctr"/>
+          <a:lstStyle/>
+          <a:p>
+            <a:pPr algn="ctr"/>
+          </a:p>
+        </p:txBody>
+      </p:sp>
+      <p:sp>
+        <p:nvSpPr>
+          <p:cNvPr id="4" name="TextBox 3"/>
+          <p:cNvSpPr txBox="1"/>
+          <p:nvPr/>
+        </p:nvSpPr>
+        <p:spPr>
+          <a:xfrm>
+            <a:off x="10881360" y="384048"/>
+            <a:ext cx="548640" cy="274320"/>
+          </a:xfrm>
+          <a:prstGeom prst="rect">
+            <a:avLst/>
+          </a:prstGeom>
+          <a:noFill/>
+        </p:spPr>
+        <p:txBody>
+          <a:bodyPr wrap="square" anchor="t" lIns="0" rIns="0" tIns="0" bIns="0">
+            <a:spAutoFit/>
+          </a:bodyPr>
+          <a:lstStyle/>
+          <a:p>
+            <a:pPr algn="r">
+              <a:defRPr sz="1000" b="0">
+                <a:solidFill>
+                  <a:srgbClr val="272C34"/>
+                </a:solidFill>
+              </a:defRPr>
+            </a:pPr>
+            <a:r>
+              <a:t>12</a:t>
+            </a:r>
+          </a:p>
+        </p:txBody>
+      </p:sp>
+      <p:sp>
+        <p:nvSpPr>
+          <p:cNvPr id="5" name="Rounded Rectangle 4"/>
+          <p:cNvSpPr/>
+          <p:nvPr/>
+        </p:nvSpPr>
+        <p:spPr>
+          <a:xfrm>
+            <a:off x="868680" y="1783080"/>
+            <a:ext cx="4754880" cy="2011680"/>
+          </a:xfrm>
+          <a:prstGeom prst="roundRect">
+            <a:avLst/>
+          </a:prstGeom>
+          <a:solidFill>
+            <a:srgbClr val="FFFFFF"/>
+          </a:solidFill>
+          <a:ln>
+            <a:solidFill>
+              <a:srgbClr val="FFFFFF"/>
+            </a:solidFill>
+          </a:ln>
+        </p:spPr>
+        <p:style>
+          <a:lnRef idx="1">
+            <a:schemeClr val="accent1"/>
+          </a:lnRef>
+          <a:fillRef idx="3">
+            <a:schemeClr val="accent1"/>
+          </a:fillRef>
+          <a:effectRef idx="2">
+            <a:schemeClr val="accent1"/>
+          </a:effectRef>
+          <a:fontRef idx="minor">
+            <a:schemeClr val="lt1"/>
+          </a:fontRef>
+        </p:style>
+        <p:txBody>
+          <a:bodyPr rtlCol="0" anchor="ctr" wrap="square" lIns="164592" rIns="164592" tIns="128016" bIns="109728"/>
+          <a:lstStyle/>
+          <a:p>
+            <a:pPr algn="ctr">
+              <a:defRPr sz="1600" b="1">
+                <a:solidFill>
+                  <a:srgbClr val="1E2761"/>
+                </a:solidFill>
+              </a:defRPr>
+            </a:pPr>
+            <a:r>
+              <a:t>Where AI helped</a:t>
+            </a:r>
+          </a:p>
+          <a:p>
+            <a:pPr>
+              <a:defRPr sz="1200">
+                <a:solidFill>
+                  <a:srgbClr val="272C34"/>
+                </a:solidFill>
+              </a:defRPr>
+            </a:pPr>
+            <a:r>
+              <a:t>Requirement extraction</a:t>
+            </a:r>
+            <a:br/>
+            <a:r>
+              <a:t>Planning and decomposition</a:t>
+            </a:r>
+            <a:br/>
+            <a:r>
+              <a:t>API and documentation structuring</a:t>
+            </a:r>
+            <a:br/>
+            <a:r>
+              <a:t>Suggestion review for tests and materials</a:t>
+            </a:r>
+          </a:p>
+        </p:txBody>
+      </p:sp>
+      <p:sp>
+        <p:nvSpPr>
+          <p:cNvPr id="6" name="Rounded Rectangle 5"/>
+          <p:cNvSpPr/>
+          <p:nvPr/>
+        </p:nvSpPr>
+        <p:spPr>
+          <a:xfrm>
+            <a:off x="5989320" y="1783080"/>
+            <a:ext cx="4663440" cy="2011680"/>
+          </a:xfrm>
+          <a:prstGeom prst="roundRect">
+            <a:avLst/>
+          </a:prstGeom>
+          <a:solidFill>
+            <a:srgbClr val="E7E8D1"/>
+          </a:solidFill>
+          <a:ln>
+            <a:solidFill>
+              <a:srgbClr val="E7E8D1"/>
+            </a:solidFill>
+          </a:ln>
+        </p:spPr>
+        <p:style>
+          <a:lnRef idx="1">
+            <a:schemeClr val="accent1"/>
+          </a:lnRef>
+          <a:fillRef idx="3">
+            <a:schemeClr val="accent1"/>
+          </a:fillRef>
+          <a:effectRef idx="2">
+            <a:schemeClr val="accent1"/>
+          </a:effectRef>
+          <a:fontRef idx="minor">
+            <a:schemeClr val="lt1"/>
+          </a:fontRef>
+        </p:style>
+        <p:txBody>
+          <a:bodyPr rtlCol="0" anchor="ctr" wrap="square" lIns="164592" rIns="164592" tIns="128016" bIns="109728"/>
+          <a:lstStyle/>
+          <a:p>
+            <a:pPr algn="ctr">
+              <a:defRPr sz="1600" b="1">
+                <a:solidFill>
+                  <a:srgbClr val="1E2761"/>
+                </a:solidFill>
+              </a:defRPr>
+            </a:pPr>
+            <a:r>
+              <a:t>Human control</a:t>
+            </a:r>
+          </a:p>
+          <a:p>
+            <a:pPr>
+              <a:defRPr sz="1200">
+                <a:solidFill>
+                  <a:srgbClr val="272C34"/>
+                </a:solidFill>
+              </a:defRPr>
+            </a:pPr>
+            <a:r>
+              <a:t>Scope was reduced manually</a:t>
+            </a:r>
+            <a:br/>
+            <a:r>
+              <a:t>Weak suggestions were rejected</a:t>
+            </a:r>
+            <a:br/>
+            <a:r>
+              <a:t>Tests and exports were verified locally</a:t>
+            </a:r>
+            <a:br/>
+            <a:r>
+              <a:t>Final tradeoffs were chosen deliberately</a:t>
+            </a:r>
+          </a:p>
+        </p:txBody>
+      </p:sp>
+      <p:sp>
+        <p:nvSpPr>
+          <p:cNvPr id="7" name="TextBox 6"/>
+          <p:cNvSpPr txBox="1"/>
+          <p:nvPr/>
+        </p:nvSpPr>
+        <p:spPr>
+          <a:xfrm>
+            <a:off x="868680" y="4343400"/>
+            <a:ext cx="10149840" cy="822960"/>
+          </a:xfrm>
+          <a:prstGeom prst="rect">
+            <a:avLst/>
+          </a:prstGeom>
+          <a:noFill/>
+        </p:spPr>
+        <p:txBody>
+          <a:bodyPr wrap="square" anchor="t" lIns="0" rIns="0" tIns="0" bIns="0">
+            <a:spAutoFit/>
+          </a:bodyPr>
+          <a:lstStyle/>
+          <a:p>
+            <a:pPr algn="l">
+              <a:defRPr sz="1800" b="0">
+                <a:solidFill>
+                  <a:srgbClr val="272C34"/>
+                </a:solidFill>
+              </a:defRPr>
+            </a:pPr>
+            <a:r>
+              <a:t>The repository includes both a GenAI declaration appendix and a representative conversation logs appendix.</a:t>
+            </a:r>
+          </a:p>
+        </p:txBody>
+      </p:sp>
+    </p:spTree>
+  </p:cSld>
+  <p:clrMapOvr>
+    <a:masterClrMapping/>
+  </p:clrMapOvr>
+</p:sld>
+</file>
+
+<file path=ppt/slides/slide13.xml><?xml version="1.0" encoding="utf-8"?>
+<p:sld xmlns:a="http://schemas.openxmlformats.org/drawingml/2006/main" xmlns:p="http://schemas.openxmlformats.org/presentationml/2006/main" xmlns:r="http://schemas.openxmlformats.org/officeDocument/2006/relationships">
+  <p:cSld>
+    <p:bg>
+      <p:bgPr>
+        <a:solidFill>
+          <a:srgbClr val="1E2761"/>
+        </a:solidFill>
+        <a:effectLst/>
+      </p:bgPr>
+    </p:bg>
+    <p:spTree>
+      <p:nvGrpSpPr>
+        <p:cNvPr id="1" name=""/>
+        <p:cNvGrpSpPr/>
+        <p:nvPr/>
+      </p:nvGrpSpPr>
+      <p:grpSpPr/>
+      <p:sp>
+        <p:nvSpPr>
+          <p:cNvPr id="2" name="TextBox 1"/>
+          <p:cNvSpPr txBox="1"/>
+          <p:nvPr/>
+        </p:nvSpPr>
+        <p:spPr>
+          <a:xfrm>
+            <a:off x="640080" y="411480"/>
+            <a:ext cx="8412480" cy="640080"/>
+          </a:xfrm>
+          <a:prstGeom prst="rect">
+            <a:avLst/>
+          </a:prstGeom>
+          <a:noFill/>
+        </p:spPr>
+        <p:txBody>
+          <a:bodyPr wrap="square" anchor="t" lIns="0" rIns="0" tIns="0" bIns="0">
+            <a:spAutoFit/>
+          </a:bodyPr>
+          <a:lstStyle/>
+          <a:p>
+            <a:pPr algn="l">
+              <a:defRPr sz="2800" b="1">
                 <a:solidFill>
                   <a:srgbClr val="FFFFFF"/>
                 </a:solidFill>
               </a:defRPr>
             </a:pPr>
             <a:r>
-              <a:t>SQLite is appropriate for coursework-scale delivery but not for large concurrent traffic. The current recommendation engine favors explainability over ML complexity, leaving room for future ranking improvements.</a:t>
+              <a:t>Demo Flow, Limitations, and Next Steps</a:t>
+            </a:r>
+          </a:p>
+        </p:txBody>
+      </p:sp>
+      <p:sp>
+        <p:nvSpPr>
+          <p:cNvPr id="3" name="Rectangle 2"/>
+          <p:cNvSpPr/>
+          <p:nvPr/>
+        </p:nvSpPr>
+        <p:spPr>
+          <a:xfrm>
+            <a:off x="640080" y="1188720"/>
+            <a:ext cx="1325880" cy="109728"/>
+          </a:xfrm>
+          <a:prstGeom prst="rect">
+            <a:avLst/>
+          </a:prstGeom>
+          <a:solidFill>
+            <a:srgbClr val="F96167"/>
+          </a:solidFill>
+          <a:ln>
+            <a:noFill/>
+          </a:ln>
+        </p:spPr>
+        <p:style>
+          <a:lnRef idx="1">
+            <a:schemeClr val="accent1"/>
+          </a:lnRef>
+          <a:fillRef idx="3">
+            <a:schemeClr val="accent1"/>
+          </a:fillRef>
+          <a:effectRef idx="2">
+            <a:schemeClr val="accent1"/>
+          </a:effectRef>
+          <a:fontRef idx="minor">
+            <a:schemeClr val="lt1"/>
+          </a:fontRef>
+        </p:style>
+        <p:txBody>
+          <a:bodyPr rtlCol="0" anchor="ctr"/>
+          <a:lstStyle/>
+          <a:p>
+            <a:pPr algn="ctr"/>
+          </a:p>
+        </p:txBody>
+      </p:sp>
+      <p:sp>
+        <p:nvSpPr>
+          <p:cNvPr id="4" name="TextBox 3"/>
+          <p:cNvSpPr txBox="1"/>
+          <p:nvPr/>
+        </p:nvSpPr>
+        <p:spPr>
+          <a:xfrm>
+            <a:off x="10881360" y="384048"/>
+            <a:ext cx="548640" cy="274320"/>
+          </a:xfrm>
+          <a:prstGeom prst="rect">
+            <a:avLst/>
+          </a:prstGeom>
+          <a:noFill/>
+        </p:spPr>
+        <p:txBody>
+          <a:bodyPr wrap="square" anchor="t" lIns="0" rIns="0" tIns="0" bIns="0">
+            <a:spAutoFit/>
+          </a:bodyPr>
+          <a:lstStyle/>
+          <a:p>
+            <a:pPr algn="r">
+              <a:defRPr sz="1000" b="0">
+                <a:solidFill>
+                  <a:srgbClr val="FFFFFF"/>
+                </a:solidFill>
+              </a:defRPr>
+            </a:pPr>
+            <a:r>
+              <a:t>13</a:t>
             </a:r>
           </a:p>
         </p:txBody>
@@ -3400,8 +4647,8 @@
         </p:nvSpPr>
         <p:spPr>
           <a:xfrm>
-            <a:off x="9966960" y="6217920"/>
-            <a:ext cx="1005840" cy="274320"/>
+            <a:off x="868680" y="1783080"/>
+            <a:ext cx="10058400" cy="3566160"/>
           </a:xfrm>
           <a:prstGeom prst="rect">
             <a:avLst/>
@@ -3409,20 +4656,44 @@
           <a:noFill/>
         </p:spPr>
         <p:txBody>
-          <a:bodyPr wrap="none">
+          <a:bodyPr wrap="square" lIns="0" rIns="0" tIns="0" bIns="0">
             <a:spAutoFit/>
           </a:bodyPr>
           <a:lstStyle/>
           <a:p>
-            <a:pPr algn="r">
-              <a:defRPr sz="1000">
+            <a:pPr>
+              <a:defRPr sz="1800">
                 <a:solidFill>
                   <a:srgbClr val="FFFFFF"/>
                 </a:solidFill>
               </a:defRPr>
             </a:pPr>
             <a:r>
-              <a:t>10</a:t>
+              <a:t>Demo flow: register, import data, browse catalog, add bookshelf entry, create review, request recommendations, inspect analytics</a:t>
+            </a:r>
+          </a:p>
+          <a:p>
+            <a:pPr>
+              <a:defRPr sz="1800">
+                <a:solidFill>
+                  <a:srgbClr val="FFFFFF"/>
+                </a:solidFill>
+              </a:defRPr>
+            </a:pPr>
+            <a:r>
+              <a:t>Limitations: SQLite scale, heuristic ranking, hosting still requires external platform provisioning</a:t>
+            </a:r>
+          </a:p>
+          <a:p>
+            <a:pPr>
+              <a:defRPr sz="1800">
+                <a:solidFill>
+                  <a:srgbClr val="FFFFFF"/>
+                </a:solidFill>
+              </a:defRPr>
+            </a:pPr>
+            <a:r>
+              <a:t>Next steps: richer ranking, stronger deployment hardening, more advanced filtering and caching</a:t>
             </a:r>
           </a:p>
         </p:txBody>
@@ -3441,7 +4712,7 @@
     <p:bg>
       <p:bgPr>
         <a:solidFill>
-          <a:srgbClr val="F5F6F0"/>
+          <a:srgbClr val="F7F4EA"/>
         </a:solidFill>
         <a:effectLst/>
       </p:bgPr>
@@ -3461,8 +4732,8 @@
         </p:nvSpPr>
         <p:spPr>
           <a:xfrm>
-            <a:off x="731520" y="548640"/>
-            <a:ext cx="10607040" cy="822960"/>
+            <a:off x="640080" y="411480"/>
+            <a:ext cx="8412480" cy="640080"/>
           </a:xfrm>
           <a:prstGeom prst="rect">
             <a:avLst/>
@@ -3470,12 +4741,12 @@
           <a:noFill/>
         </p:spPr>
         <p:txBody>
-          <a:bodyPr wrap="square">
+          <a:bodyPr wrap="square" anchor="t" lIns="0" rIns="0" tIns="0" bIns="0">
             <a:spAutoFit/>
           </a:bodyPr>
           <a:lstStyle/>
           <a:p>
-            <a:pPr>
+            <a:pPr algn="l">
               <a:defRPr sz="2800" b="1">
                 <a:solidFill>
                   <a:srgbClr val="272C34"/>
@@ -3496,14 +4767,14 @@
         </p:nvSpPr>
         <p:spPr>
           <a:xfrm>
-            <a:off x="731520" y="1554480"/>
-            <a:ext cx="1188720" cy="128016"/>
+            <a:off x="640080" y="1188720"/>
+            <a:ext cx="1325880" cy="109728"/>
           </a:xfrm>
           <a:prstGeom prst="rect">
             <a:avLst/>
           </a:prstGeom>
           <a:solidFill>
-            <a:srgbClr val="065A82"/>
+            <a:srgbClr val="F96167"/>
           </a:solidFill>
           <a:ln>
             <a:noFill/>
@@ -3539,8 +4810,241 @@
         </p:nvSpPr>
         <p:spPr>
           <a:xfrm>
-            <a:off x="868680" y="1874519"/>
-            <a:ext cx="10332720" cy="3566160"/>
+            <a:off x="10881360" y="384048"/>
+            <a:ext cx="548640" cy="274320"/>
+          </a:xfrm>
+          <a:prstGeom prst="rect">
+            <a:avLst/>
+          </a:prstGeom>
+          <a:noFill/>
+        </p:spPr>
+        <p:txBody>
+          <a:bodyPr wrap="square" anchor="t" lIns="0" rIns="0" tIns="0" bIns="0">
+            <a:spAutoFit/>
+          </a:bodyPr>
+          <a:lstStyle/>
+          <a:p>
+            <a:pPr algn="r">
+              <a:defRPr sz="1000" b="0">
+                <a:solidFill>
+                  <a:srgbClr val="272C34"/>
+                </a:solidFill>
+              </a:defRPr>
+            </a:pPr>
+            <a:r>
+              <a:t>02</a:t>
+            </a:r>
+          </a:p>
+        </p:txBody>
+      </p:sp>
+      <p:sp>
+        <p:nvSpPr>
+          <p:cNvPr id="5" name="Rounded Rectangle 4"/>
+          <p:cNvSpPr/>
+          <p:nvPr/>
+        </p:nvSpPr>
+        <p:spPr>
+          <a:xfrm>
+            <a:off x="731520" y="1645920"/>
+            <a:ext cx="3383280" cy="1828800"/>
+          </a:xfrm>
+          <a:prstGeom prst="roundRect">
+            <a:avLst/>
+          </a:prstGeom>
+          <a:solidFill>
+            <a:srgbClr val="FFFFFF"/>
+          </a:solidFill>
+          <a:ln>
+            <a:solidFill>
+              <a:srgbClr val="FFFFFF"/>
+            </a:solidFill>
+          </a:ln>
+        </p:spPr>
+        <p:style>
+          <a:lnRef idx="1">
+            <a:schemeClr val="accent1"/>
+          </a:lnRef>
+          <a:fillRef idx="3">
+            <a:schemeClr val="accent1"/>
+          </a:fillRef>
+          <a:effectRef idx="2">
+            <a:schemeClr val="accent1"/>
+          </a:effectRef>
+          <a:fontRef idx="minor">
+            <a:schemeClr val="lt1"/>
+          </a:fontRef>
+        </p:style>
+        <p:txBody>
+          <a:bodyPr rtlCol="0" anchor="ctr" wrap="square" lIns="164592" rIns="164592" tIns="128016" bIns="109728"/>
+          <a:lstStyle/>
+          <a:p>
+            <a:pPr algn="ctr">
+              <a:defRPr sz="1600" b="1">
+                <a:solidFill>
+                  <a:srgbClr val="1E2761"/>
+                </a:solidFill>
+              </a:defRPr>
+            </a:pPr>
+            <a:r>
+              <a:t>Why not a proxy?</a:t>
+            </a:r>
+          </a:p>
+          <a:p>
+            <a:pPr>
+              <a:defRPr sz="1200">
+                <a:solidFill>
+                  <a:srgbClr val="272C34"/>
+                </a:solidFill>
+              </a:defRPr>
+            </a:pPr>
+            <a:r>
+              <a:t>Public book APIs expose metadata, but not personal reading state, private bookshelf logic, or coursework-specific analytics.</a:t>
+            </a:r>
+          </a:p>
+        </p:txBody>
+      </p:sp>
+      <p:sp>
+        <p:nvSpPr>
+          <p:cNvPr id="6" name="Rounded Rectangle 5"/>
+          <p:cNvSpPr/>
+          <p:nvPr/>
+        </p:nvSpPr>
+        <p:spPr>
+          <a:xfrm>
+            <a:off x="4389120" y="1645920"/>
+            <a:ext cx="3383280" cy="1828800"/>
+          </a:xfrm>
+          <a:prstGeom prst="roundRect">
+            <a:avLst/>
+          </a:prstGeom>
+          <a:solidFill>
+            <a:srgbClr val="FFFFFF"/>
+          </a:solidFill>
+          <a:ln>
+            <a:solidFill>
+              <a:srgbClr val="FFFFFF"/>
+            </a:solidFill>
+          </a:ln>
+        </p:spPr>
+        <p:style>
+          <a:lnRef idx="1">
+            <a:schemeClr val="accent1"/>
+          </a:lnRef>
+          <a:fillRef idx="3">
+            <a:schemeClr val="accent1"/>
+          </a:fillRef>
+          <a:effectRef idx="2">
+            <a:schemeClr val="accent1"/>
+          </a:effectRef>
+          <a:fontRef idx="minor">
+            <a:schemeClr val="lt1"/>
+          </a:fontRef>
+        </p:style>
+        <p:txBody>
+          <a:bodyPr rtlCol="0" anchor="ctr" wrap="square" lIns="164592" rIns="164592" tIns="128016" bIns="109728"/>
+          <a:lstStyle/>
+          <a:p>
+            <a:pPr algn="ctr">
+              <a:defRPr sz="1600" b="1">
+                <a:solidFill>
+                  <a:srgbClr val="1E2761"/>
+                </a:solidFill>
+              </a:defRPr>
+            </a:pPr>
+            <a:r>
+              <a:t>Coursework fit</a:t>
+            </a:r>
+          </a:p>
+          <a:p>
+            <a:pPr>
+              <a:defRPr sz="1200">
+                <a:solidFill>
+                  <a:srgbClr val="272C34"/>
+                </a:solidFill>
+              </a:defRPr>
+            </a:pPr>
+            <a:r>
+              <a:t>The project demonstrates CRUD, authentication, data ingestion, testing, API documentation, and version-controlled delivery.</a:t>
+            </a:r>
+          </a:p>
+        </p:txBody>
+      </p:sp>
+      <p:sp>
+        <p:nvSpPr>
+          <p:cNvPr id="7" name="Rounded Rectangle 6"/>
+          <p:cNvSpPr/>
+          <p:nvPr/>
+        </p:nvSpPr>
+        <p:spPr>
+          <a:xfrm>
+            <a:off x="8046720" y="1645920"/>
+            <a:ext cx="3383280" cy="1828800"/>
+          </a:xfrm>
+          <a:prstGeom prst="roundRect">
+            <a:avLst/>
+          </a:prstGeom>
+          <a:solidFill>
+            <a:srgbClr val="FFFFFF"/>
+          </a:solidFill>
+          <a:ln>
+            <a:solidFill>
+              <a:srgbClr val="FFFFFF"/>
+            </a:solidFill>
+          </a:ln>
+        </p:spPr>
+        <p:style>
+          <a:lnRef idx="1">
+            <a:schemeClr val="accent1"/>
+          </a:lnRef>
+          <a:fillRef idx="3">
+            <a:schemeClr val="accent1"/>
+          </a:fillRef>
+          <a:effectRef idx="2">
+            <a:schemeClr val="accent1"/>
+          </a:effectRef>
+          <a:fontRef idx="minor">
+            <a:schemeClr val="lt1"/>
+          </a:fontRef>
+        </p:style>
+        <p:txBody>
+          <a:bodyPr rtlCol="0" anchor="ctr" wrap="square" lIns="164592" rIns="164592" tIns="128016" bIns="109728"/>
+          <a:lstStyle/>
+          <a:p>
+            <a:pPr algn="ctr">
+              <a:defRPr sz="1600" b="1">
+                <a:solidFill>
+                  <a:srgbClr val="1E2761"/>
+                </a:solidFill>
+              </a:defRPr>
+            </a:pPr>
+            <a:r>
+              <a:t>Chosen scope</a:t>
+            </a:r>
+          </a:p>
+          <a:p>
+            <a:pPr>
+              <a:defRPr sz="1200">
+                <a:solidFill>
+                  <a:srgbClr val="272C34"/>
+                </a:solidFill>
+              </a:defRPr>
+            </a:pPr>
+            <a:r>
+              <a:t>Book, author, genre, bookshelf, review, recommendation, and analytics endpoints on top of local SQLite data.</a:t>
+            </a:r>
+          </a:p>
+        </p:txBody>
+      </p:sp>
+      <p:sp>
+        <p:nvSpPr>
+          <p:cNvPr id="8" name="TextBox 7"/>
+          <p:cNvSpPr txBox="1"/>
+          <p:nvPr/>
+        </p:nvSpPr>
+        <p:spPr>
+          <a:xfrm>
+            <a:off x="868680" y="3977639"/>
+            <a:ext cx="10241280" cy="3566160"/>
           </a:xfrm>
           <a:prstGeom prst="rect">
             <a:avLst/>
@@ -3553,7 +5057,7 @@
           </a:bodyPr>
           <a:lstStyle/>
           <a:p>
-            <a:pPr algn="l">
+            <a:pPr>
               <a:defRPr sz="1800">
                 <a:solidFill>
                   <a:srgbClr val="272C34"/>
@@ -3561,42 +5065,43 @@
               </a:defRPr>
             </a:pPr>
             <a:r>
-              <a:t>Public metadata alone does not support a user's reading workflow. BookScope stores imported book metadata locally and builds CRUD, reviews, recommendations, and analytics on top of that local database.</a:t>
-            </a:r>
-          </a:p>
-        </p:txBody>
-      </p:sp>
-      <p:sp>
-        <p:nvSpPr>
-          <p:cNvPr id="5" name="TextBox 4"/>
-          <p:cNvSpPr txBox="1"/>
-          <p:nvPr/>
-        </p:nvSpPr>
-        <p:spPr>
-          <a:xfrm>
-            <a:off x="9966960" y="6217920"/>
-            <a:ext cx="1005840" cy="274320"/>
-          </a:xfrm>
-          <a:prstGeom prst="rect">
-            <a:avLst/>
-          </a:prstGeom>
-          <a:noFill/>
-        </p:spPr>
-        <p:txBody>
-          <a:bodyPr wrap="none">
-            <a:spAutoFit/>
-          </a:bodyPr>
-          <a:lstStyle/>
-          <a:p>
-            <a:pPr algn="r">
-              <a:defRPr sz="1000">
+              <a:t>Public catalog browsing</a:t>
+            </a:r>
+          </a:p>
+          <a:p>
+            <a:pPr>
+              <a:defRPr sz="1800">
                 <a:solidFill>
                   <a:srgbClr val="272C34"/>
                 </a:solidFill>
               </a:defRPr>
             </a:pPr>
             <a:r>
-              <a:t>02</a:t>
+              <a:t>Authenticated bookshelf and review actions</a:t>
+            </a:r>
+          </a:p>
+          <a:p>
+            <a:pPr>
+              <a:defRPr sz="1800">
+                <a:solidFill>
+                  <a:srgbClr val="272C34"/>
+                </a:solidFill>
+              </a:defRPr>
+            </a:pPr>
+            <a:r>
+              <a:t>Explainable recommendation results</a:t>
+            </a:r>
+          </a:p>
+          <a:p>
+            <a:pPr>
+              <a:defRPr sz="1800">
+                <a:solidFill>
+                  <a:srgbClr val="272C34"/>
+                </a:solidFill>
+              </a:defRPr>
+            </a:pPr>
+            <a:r>
+              <a:t>Analytics for genres, ratings, and reading summary</a:t>
             </a:r>
           </a:p>
         </p:txBody>
@@ -3615,7 +5120,7 @@
     <p:bg>
       <p:bgPr>
         <a:solidFill>
-          <a:srgbClr val="F5F6F0"/>
+          <a:srgbClr val="F7F4EA"/>
         </a:solidFill>
         <a:effectLst/>
       </p:bgPr>
@@ -3635,8 +5140,8 @@
         </p:nvSpPr>
         <p:spPr>
           <a:xfrm>
-            <a:off x="731520" y="548640"/>
-            <a:ext cx="10607040" cy="822960"/>
+            <a:off x="640080" y="411480"/>
+            <a:ext cx="8412480" cy="640080"/>
           </a:xfrm>
           <a:prstGeom prst="rect">
             <a:avLst/>
@@ -3644,12 +5149,12 @@
           <a:noFill/>
         </p:spPr>
         <p:txBody>
-          <a:bodyPr wrap="square">
+          <a:bodyPr wrap="square" anchor="t" lIns="0" rIns="0" tIns="0" bIns="0">
             <a:spAutoFit/>
           </a:bodyPr>
           <a:lstStyle/>
           <a:p>
-            <a:pPr>
+            <a:pPr algn="l">
               <a:defRPr sz="2800" b="1">
                 <a:solidFill>
                   <a:srgbClr val="272C34"/>
@@ -3657,7 +5162,7 @@
               </a:defRPr>
             </a:pPr>
             <a:r>
-              <a:t>Architecture</a:t>
+              <a:t>Architecture Overview</a:t>
             </a:r>
           </a:p>
         </p:txBody>
@@ -3670,14 +5175,14 @@
         </p:nvSpPr>
         <p:spPr>
           <a:xfrm>
-            <a:off x="731520" y="1554480"/>
-            <a:ext cx="1188720" cy="128016"/>
+            <a:off x="640080" y="1188720"/>
+            <a:ext cx="1325880" cy="109728"/>
           </a:xfrm>
           <a:prstGeom prst="rect">
             <a:avLst/>
           </a:prstGeom>
           <a:solidFill>
-            <a:srgbClr val="F96167"/>
+            <a:srgbClr val="065A82"/>
           </a:solidFill>
           <a:ln>
             <a:noFill/>
@@ -3713,8 +5218,8 @@
         </p:nvSpPr>
         <p:spPr>
           <a:xfrm>
-            <a:off x="868680" y="1874519"/>
-            <a:ext cx="10332720" cy="3566160"/>
+            <a:off x="10881360" y="384048"/>
+            <a:ext cx="548640" cy="274320"/>
           </a:xfrm>
           <a:prstGeom prst="rect">
             <a:avLst/>
@@ -3722,34 +5227,298 @@
           <a:noFill/>
         </p:spPr>
         <p:txBody>
-          <a:bodyPr wrap="square" lIns="0" rIns="0" tIns="0" bIns="0">
+          <a:bodyPr wrap="square" anchor="t" lIns="0" rIns="0" tIns="0" bIns="0">
             <a:spAutoFit/>
           </a:bodyPr>
           <a:lstStyle/>
           <a:p>
-            <a:pPr algn="l">
-              <a:defRPr sz="1800">
+            <a:pPr algn="r">
+              <a:defRPr sz="1000" b="0">
                 <a:solidFill>
                   <a:srgbClr val="272C34"/>
                 </a:solidFill>
               </a:defRPr>
             </a:pPr>
             <a:r>
-              <a:t>The project is organized into accounts, catalog, engagement, and analytics modules. Django REST Framework handles routing, serialization, filtering, pagination, and JWT-protected endpoints.</a:t>
-            </a:r>
-          </a:p>
-        </p:txBody>
-      </p:sp>
-      <p:sp>
-        <p:nvSpPr>
-          <p:cNvPr id="5" name="TextBox 4"/>
+              <a:t>03</a:t>
+            </a:r>
+          </a:p>
+        </p:txBody>
+      </p:sp>
+      <p:sp>
+        <p:nvSpPr>
+          <p:cNvPr id="5" name="Rounded Rectangle 4"/>
+          <p:cNvSpPr/>
+          <p:nvPr/>
+        </p:nvSpPr>
+        <p:spPr>
+          <a:xfrm>
+            <a:off x="822960" y="1828800"/>
+            <a:ext cx="2148840" cy="1691640"/>
+          </a:xfrm>
+          <a:prstGeom prst="roundRect">
+            <a:avLst/>
+          </a:prstGeom>
+          <a:solidFill>
+            <a:srgbClr val="FFFFFF"/>
+          </a:solidFill>
+          <a:ln>
+            <a:solidFill>
+              <a:srgbClr val="FFFFFF"/>
+            </a:solidFill>
+          </a:ln>
+        </p:spPr>
+        <p:style>
+          <a:lnRef idx="1">
+            <a:schemeClr val="accent1"/>
+          </a:lnRef>
+          <a:fillRef idx="3">
+            <a:schemeClr val="accent1"/>
+          </a:fillRef>
+          <a:effectRef idx="2">
+            <a:schemeClr val="accent1"/>
+          </a:effectRef>
+          <a:fontRef idx="minor">
+            <a:schemeClr val="lt1"/>
+          </a:fontRef>
+        </p:style>
+        <p:txBody>
+          <a:bodyPr rtlCol="0" anchor="ctr" wrap="square" lIns="164592" rIns="164592" tIns="128016" bIns="109728"/>
+          <a:lstStyle/>
+          <a:p>
+            <a:pPr algn="ctr">
+              <a:defRPr sz="1600" b="1">
+                <a:solidFill>
+                  <a:srgbClr val="1E2761"/>
+                </a:solidFill>
+              </a:defRPr>
+            </a:pPr>
+            <a:r>
+              <a:t>accounts</a:t>
+            </a:r>
+          </a:p>
+          <a:p>
+            <a:pPr>
+              <a:defRPr sz="1200">
+                <a:solidFill>
+                  <a:srgbClr val="272C34"/>
+                </a:solidFill>
+              </a:defRPr>
+            </a:pPr>
+            <a:r>
+              <a:t>Register, login, JWT, current user</a:t>
+            </a:r>
+          </a:p>
+        </p:txBody>
+      </p:sp>
+      <p:sp>
+        <p:nvSpPr>
+          <p:cNvPr id="6" name="Rounded Rectangle 5"/>
+          <p:cNvSpPr/>
+          <p:nvPr/>
+        </p:nvSpPr>
+        <p:spPr>
+          <a:xfrm>
+            <a:off x="3566160" y="1828800"/>
+            <a:ext cx="2148840" cy="1691640"/>
+          </a:xfrm>
+          <a:prstGeom prst="roundRect">
+            <a:avLst/>
+          </a:prstGeom>
+          <a:solidFill>
+            <a:srgbClr val="FFFFFF"/>
+          </a:solidFill>
+          <a:ln>
+            <a:solidFill>
+              <a:srgbClr val="FFFFFF"/>
+            </a:solidFill>
+          </a:ln>
+        </p:spPr>
+        <p:style>
+          <a:lnRef idx="1">
+            <a:schemeClr val="accent1"/>
+          </a:lnRef>
+          <a:fillRef idx="3">
+            <a:schemeClr val="accent1"/>
+          </a:fillRef>
+          <a:effectRef idx="2">
+            <a:schemeClr val="accent1"/>
+          </a:effectRef>
+          <a:fontRef idx="minor">
+            <a:schemeClr val="lt1"/>
+          </a:fontRef>
+        </p:style>
+        <p:txBody>
+          <a:bodyPr rtlCol="0" anchor="ctr" wrap="square" lIns="164592" rIns="164592" tIns="128016" bIns="109728"/>
+          <a:lstStyle/>
+          <a:p>
+            <a:pPr algn="ctr">
+              <a:defRPr sz="1600" b="1">
+                <a:solidFill>
+                  <a:srgbClr val="1E2761"/>
+                </a:solidFill>
+              </a:defRPr>
+            </a:pPr>
+            <a:r>
+              <a:t>catalog</a:t>
+            </a:r>
+          </a:p>
+          <a:p>
+            <a:pPr>
+              <a:defRPr sz="1200">
+                <a:solidFill>
+                  <a:srgbClr val="272C34"/>
+                </a:solidFill>
+              </a:defRPr>
+            </a:pPr>
+            <a:r>
+              <a:t>Books, authors, genres, filters, import</a:t>
+            </a:r>
+          </a:p>
+        </p:txBody>
+      </p:sp>
+      <p:sp>
+        <p:nvSpPr>
+          <p:cNvPr id="7" name="Rounded Rectangle 6"/>
+          <p:cNvSpPr/>
+          <p:nvPr/>
+        </p:nvSpPr>
+        <p:spPr>
+          <a:xfrm>
+            <a:off x="6309360" y="1828800"/>
+            <a:ext cx="2148840" cy="1691640"/>
+          </a:xfrm>
+          <a:prstGeom prst="roundRect">
+            <a:avLst/>
+          </a:prstGeom>
+          <a:solidFill>
+            <a:srgbClr val="FFFFFF"/>
+          </a:solidFill>
+          <a:ln>
+            <a:solidFill>
+              <a:srgbClr val="FFFFFF"/>
+            </a:solidFill>
+          </a:ln>
+        </p:spPr>
+        <p:style>
+          <a:lnRef idx="1">
+            <a:schemeClr val="accent1"/>
+          </a:lnRef>
+          <a:fillRef idx="3">
+            <a:schemeClr val="accent1"/>
+          </a:fillRef>
+          <a:effectRef idx="2">
+            <a:schemeClr val="accent1"/>
+          </a:effectRef>
+          <a:fontRef idx="minor">
+            <a:schemeClr val="lt1"/>
+          </a:fontRef>
+        </p:style>
+        <p:txBody>
+          <a:bodyPr rtlCol="0" anchor="ctr" wrap="square" lIns="164592" rIns="164592" tIns="128016" bIns="109728"/>
+          <a:lstStyle/>
+          <a:p>
+            <a:pPr algn="ctr">
+              <a:defRPr sz="1600" b="1">
+                <a:solidFill>
+                  <a:srgbClr val="1E2761"/>
+                </a:solidFill>
+              </a:defRPr>
+            </a:pPr>
+            <a:r>
+              <a:t>engagement</a:t>
+            </a:r>
+          </a:p>
+          <a:p>
+            <a:pPr>
+              <a:defRPr sz="1200">
+                <a:solidFill>
+                  <a:srgbClr val="272C34"/>
+                </a:solidFill>
+              </a:defRPr>
+            </a:pPr>
+            <a:r>
+              <a:t>Bookshelf entries and reviews</a:t>
+            </a:r>
+          </a:p>
+        </p:txBody>
+      </p:sp>
+      <p:sp>
+        <p:nvSpPr>
+          <p:cNvPr id="8" name="Rounded Rectangle 7"/>
+          <p:cNvSpPr/>
+          <p:nvPr/>
+        </p:nvSpPr>
+        <p:spPr>
+          <a:xfrm>
+            <a:off x="9052560" y="1828800"/>
+            <a:ext cx="2148840" cy="1691640"/>
+          </a:xfrm>
+          <a:prstGeom prst="roundRect">
+            <a:avLst/>
+          </a:prstGeom>
+          <a:solidFill>
+            <a:srgbClr val="FFFFFF"/>
+          </a:solidFill>
+          <a:ln>
+            <a:solidFill>
+              <a:srgbClr val="FFFFFF"/>
+            </a:solidFill>
+          </a:ln>
+        </p:spPr>
+        <p:style>
+          <a:lnRef idx="1">
+            <a:schemeClr val="accent1"/>
+          </a:lnRef>
+          <a:fillRef idx="3">
+            <a:schemeClr val="accent1"/>
+          </a:fillRef>
+          <a:effectRef idx="2">
+            <a:schemeClr val="accent1"/>
+          </a:effectRef>
+          <a:fontRef idx="minor">
+            <a:schemeClr val="lt1"/>
+          </a:fontRef>
+        </p:style>
+        <p:txBody>
+          <a:bodyPr rtlCol="0" anchor="ctr" wrap="square" lIns="164592" rIns="164592" tIns="128016" bIns="109728"/>
+          <a:lstStyle/>
+          <a:p>
+            <a:pPr algn="ctr">
+              <a:defRPr sz="1600" b="1">
+                <a:solidFill>
+                  <a:srgbClr val="1E2761"/>
+                </a:solidFill>
+              </a:defRPr>
+            </a:pPr>
+            <a:r>
+              <a:t>analytics</a:t>
+            </a:r>
+          </a:p>
+          <a:p>
+            <a:pPr>
+              <a:defRPr sz="1200">
+                <a:solidFill>
+                  <a:srgbClr val="272C34"/>
+                </a:solidFill>
+              </a:defRPr>
+            </a:pPr>
+            <a:r>
+              <a:t>Recommendations and aggregate endpoints</a:t>
+            </a:r>
+          </a:p>
+        </p:txBody>
+      </p:sp>
+      <p:sp>
+        <p:nvSpPr>
+          <p:cNvPr id="9" name="TextBox 8"/>
           <p:cNvSpPr txBox="1"/>
           <p:nvPr/>
         </p:nvSpPr>
         <p:spPr>
           <a:xfrm>
-            <a:off x="9966960" y="6217920"/>
-            <a:ext cx="1005840" cy="274320"/>
+            <a:off x="960120" y="3977639"/>
+            <a:ext cx="10241280" cy="1097280"/>
           </a:xfrm>
           <a:prstGeom prst="rect">
             <a:avLst/>
@@ -3757,20 +5526,20 @@
           <a:noFill/>
         </p:spPr>
         <p:txBody>
-          <a:bodyPr wrap="none">
+          <a:bodyPr wrap="square" anchor="t" lIns="0" rIns="0" tIns="0" bIns="0">
             <a:spAutoFit/>
           </a:bodyPr>
           <a:lstStyle/>
           <a:p>
-            <a:pPr algn="r">
-              <a:defRPr sz="1000">
+            <a:pPr algn="l">
+              <a:defRPr sz="1800" b="0">
                 <a:solidFill>
                   <a:srgbClr val="272C34"/>
                 </a:solidFill>
               </a:defRPr>
             </a:pPr>
             <a:r>
-              <a:t>03</a:t>
+              <a:t>Django REST Framework handles routing, serializers, permissions, pagination, filtering, and schema generation. Services isolate recommendation, analytics, and ingestion logic from HTTP views.</a:t>
             </a:r>
           </a:p>
         </p:txBody>
@@ -3789,7 +5558,7 @@
     <p:bg>
       <p:bgPr>
         <a:solidFill>
-          <a:srgbClr val="F5F6F0"/>
+          <a:srgbClr val="F7F4EA"/>
         </a:solidFill>
         <a:effectLst/>
       </p:bgPr>
@@ -3809,8 +5578,8 @@
         </p:nvSpPr>
         <p:spPr>
           <a:xfrm>
-            <a:off x="731520" y="548640"/>
-            <a:ext cx="10607040" cy="822960"/>
+            <a:off x="640080" y="411480"/>
+            <a:ext cx="8412480" cy="640080"/>
           </a:xfrm>
           <a:prstGeom prst="rect">
             <a:avLst/>
@@ -3818,12 +5587,12 @@
           <a:noFill/>
         </p:spPr>
         <p:txBody>
-          <a:bodyPr wrap="square">
+          <a:bodyPr wrap="square" anchor="t" lIns="0" rIns="0" tIns="0" bIns="0">
             <a:spAutoFit/>
           </a:bodyPr>
           <a:lstStyle/>
           <a:p>
-            <a:pPr>
+            <a:pPr algn="l">
               <a:defRPr sz="2800" b="1">
                 <a:solidFill>
                   <a:srgbClr val="272C34"/>
@@ -3844,14 +5613,14 @@
         </p:nvSpPr>
         <p:spPr>
           <a:xfrm>
-            <a:off x="731520" y="1554480"/>
-            <a:ext cx="1188720" cy="128016"/>
+            <a:off x="640080" y="1188720"/>
+            <a:ext cx="1325880" cy="109728"/>
           </a:xfrm>
           <a:prstGeom prst="rect">
             <a:avLst/>
           </a:prstGeom>
           <a:solidFill>
-            <a:srgbClr val="065A82"/>
+            <a:srgbClr val="F96167"/>
           </a:solidFill>
           <a:ln>
             <a:noFill/>
@@ -3887,8 +5656,408 @@
         </p:nvSpPr>
         <p:spPr>
           <a:xfrm>
-            <a:off x="868680" y="1874519"/>
-            <a:ext cx="10332720" cy="3566160"/>
+            <a:off x="10881360" y="384048"/>
+            <a:ext cx="548640" cy="274320"/>
+          </a:xfrm>
+          <a:prstGeom prst="rect">
+            <a:avLst/>
+          </a:prstGeom>
+          <a:noFill/>
+        </p:spPr>
+        <p:txBody>
+          <a:bodyPr wrap="square" anchor="t" lIns="0" rIns="0" tIns="0" bIns="0">
+            <a:spAutoFit/>
+          </a:bodyPr>
+          <a:lstStyle/>
+          <a:p>
+            <a:pPr algn="r">
+              <a:defRPr sz="1000" b="0">
+                <a:solidFill>
+                  <a:srgbClr val="272C34"/>
+                </a:solidFill>
+              </a:defRPr>
+            </a:pPr>
+            <a:r>
+              <a:t>04</a:t>
+            </a:r>
+          </a:p>
+        </p:txBody>
+      </p:sp>
+      <p:sp>
+        <p:nvSpPr>
+          <p:cNvPr id="5" name="Rounded Rectangle 4"/>
+          <p:cNvSpPr/>
+          <p:nvPr/>
+        </p:nvSpPr>
+        <p:spPr>
+          <a:xfrm>
+            <a:off x="822960" y="1828800"/>
+            <a:ext cx="1645920" cy="1097280"/>
+          </a:xfrm>
+          <a:prstGeom prst="roundRect">
+            <a:avLst/>
+          </a:prstGeom>
+          <a:solidFill>
+            <a:srgbClr val="E7E8D1"/>
+          </a:solidFill>
+          <a:ln>
+            <a:solidFill>
+              <a:srgbClr val="E7E8D1"/>
+            </a:solidFill>
+          </a:ln>
+        </p:spPr>
+        <p:style>
+          <a:lnRef idx="1">
+            <a:schemeClr val="accent1"/>
+          </a:lnRef>
+          <a:fillRef idx="3">
+            <a:schemeClr val="accent1"/>
+          </a:fillRef>
+          <a:effectRef idx="2">
+            <a:schemeClr val="accent1"/>
+          </a:effectRef>
+          <a:fontRef idx="minor">
+            <a:schemeClr val="lt1"/>
+          </a:fontRef>
+        </p:style>
+        <p:txBody>
+          <a:bodyPr rtlCol="0" anchor="ctr" wrap="square" lIns="164592" rIns="164592" tIns="128016" bIns="109728"/>
+          <a:lstStyle/>
+          <a:p>
+            <a:pPr algn="ctr">
+              <a:defRPr sz="1600" b="1">
+                <a:solidFill>
+                  <a:srgbClr val="1E2761"/>
+                </a:solidFill>
+              </a:defRPr>
+            </a:pPr>
+            <a:r>
+              <a:t>Author</a:t>
+            </a:r>
+          </a:p>
+          <a:p>
+            <a:pPr>
+              <a:defRPr sz="1200">
+                <a:solidFill>
+                  <a:srgbClr val="272C34"/>
+                </a:solidFill>
+              </a:defRPr>
+            </a:pPr>
+            <a:r>
+              <a:t>Core entity</a:t>
+            </a:r>
+          </a:p>
+        </p:txBody>
+      </p:sp>
+      <p:sp>
+        <p:nvSpPr>
+          <p:cNvPr id="6" name="Rounded Rectangle 5"/>
+          <p:cNvSpPr/>
+          <p:nvPr/>
+        </p:nvSpPr>
+        <p:spPr>
+          <a:xfrm>
+            <a:off x="3017520" y="1828800"/>
+            <a:ext cx="1645920" cy="1097280"/>
+          </a:xfrm>
+          <a:prstGeom prst="roundRect">
+            <a:avLst/>
+          </a:prstGeom>
+          <a:solidFill>
+            <a:srgbClr val="E7E8D1"/>
+          </a:solidFill>
+          <a:ln>
+            <a:solidFill>
+              <a:srgbClr val="E7E8D1"/>
+            </a:solidFill>
+          </a:ln>
+        </p:spPr>
+        <p:style>
+          <a:lnRef idx="1">
+            <a:schemeClr val="accent1"/>
+          </a:lnRef>
+          <a:fillRef idx="3">
+            <a:schemeClr val="accent1"/>
+          </a:fillRef>
+          <a:effectRef idx="2">
+            <a:schemeClr val="accent1"/>
+          </a:effectRef>
+          <a:fontRef idx="minor">
+            <a:schemeClr val="lt1"/>
+          </a:fontRef>
+        </p:style>
+        <p:txBody>
+          <a:bodyPr rtlCol="0" anchor="ctr" wrap="square" lIns="164592" rIns="164592" tIns="128016" bIns="109728"/>
+          <a:lstStyle/>
+          <a:p>
+            <a:pPr algn="ctr">
+              <a:defRPr sz="1600" b="1">
+                <a:solidFill>
+                  <a:srgbClr val="1E2761"/>
+                </a:solidFill>
+              </a:defRPr>
+            </a:pPr>
+            <a:r>
+              <a:t>Genre</a:t>
+            </a:r>
+          </a:p>
+          <a:p>
+            <a:pPr>
+              <a:defRPr sz="1200">
+                <a:solidFill>
+                  <a:srgbClr val="272C34"/>
+                </a:solidFill>
+              </a:defRPr>
+            </a:pPr>
+            <a:r>
+              <a:t>Core entity</a:t>
+            </a:r>
+          </a:p>
+        </p:txBody>
+      </p:sp>
+      <p:sp>
+        <p:nvSpPr>
+          <p:cNvPr id="7" name="Rounded Rectangle 6"/>
+          <p:cNvSpPr/>
+          <p:nvPr/>
+        </p:nvSpPr>
+        <p:spPr>
+          <a:xfrm>
+            <a:off x="5212080" y="1828800"/>
+            <a:ext cx="1645920" cy="1097280"/>
+          </a:xfrm>
+          <a:prstGeom prst="roundRect">
+            <a:avLst/>
+          </a:prstGeom>
+          <a:solidFill>
+            <a:srgbClr val="E7E8D1"/>
+          </a:solidFill>
+          <a:ln>
+            <a:solidFill>
+              <a:srgbClr val="E7E8D1"/>
+            </a:solidFill>
+          </a:ln>
+        </p:spPr>
+        <p:style>
+          <a:lnRef idx="1">
+            <a:schemeClr val="accent1"/>
+          </a:lnRef>
+          <a:fillRef idx="3">
+            <a:schemeClr val="accent1"/>
+          </a:fillRef>
+          <a:effectRef idx="2">
+            <a:schemeClr val="accent1"/>
+          </a:effectRef>
+          <a:fontRef idx="minor">
+            <a:schemeClr val="lt1"/>
+          </a:fontRef>
+        </p:style>
+        <p:txBody>
+          <a:bodyPr rtlCol="0" anchor="ctr" wrap="square" lIns="164592" rIns="164592" tIns="128016" bIns="109728"/>
+          <a:lstStyle/>
+          <a:p>
+            <a:pPr algn="ctr">
+              <a:defRPr sz="1600" b="1">
+                <a:solidFill>
+                  <a:srgbClr val="1E2761"/>
+                </a:solidFill>
+              </a:defRPr>
+            </a:pPr>
+            <a:r>
+              <a:t>Book</a:t>
+            </a:r>
+          </a:p>
+          <a:p>
+            <a:pPr>
+              <a:defRPr sz="1200">
+                <a:solidFill>
+                  <a:srgbClr val="272C34"/>
+                </a:solidFill>
+              </a:defRPr>
+            </a:pPr>
+            <a:r>
+              <a:t>Core entity</a:t>
+            </a:r>
+          </a:p>
+        </p:txBody>
+      </p:sp>
+      <p:sp>
+        <p:nvSpPr>
+          <p:cNvPr id="8" name="Rounded Rectangle 7"/>
+          <p:cNvSpPr/>
+          <p:nvPr/>
+        </p:nvSpPr>
+        <p:spPr>
+          <a:xfrm>
+            <a:off x="7406640" y="1828800"/>
+            <a:ext cx="1645920" cy="1097280"/>
+          </a:xfrm>
+          <a:prstGeom prst="roundRect">
+            <a:avLst/>
+          </a:prstGeom>
+          <a:solidFill>
+            <a:srgbClr val="E7E8D1"/>
+          </a:solidFill>
+          <a:ln>
+            <a:solidFill>
+              <a:srgbClr val="E7E8D1"/>
+            </a:solidFill>
+          </a:ln>
+        </p:spPr>
+        <p:style>
+          <a:lnRef idx="1">
+            <a:schemeClr val="accent1"/>
+          </a:lnRef>
+          <a:fillRef idx="3">
+            <a:schemeClr val="accent1"/>
+          </a:fillRef>
+          <a:effectRef idx="2">
+            <a:schemeClr val="accent1"/>
+          </a:effectRef>
+          <a:fontRef idx="minor">
+            <a:schemeClr val="lt1"/>
+          </a:fontRef>
+        </p:style>
+        <p:txBody>
+          <a:bodyPr rtlCol="0" anchor="ctr" wrap="square" lIns="164592" rIns="164592" tIns="128016" bIns="109728"/>
+          <a:lstStyle/>
+          <a:p>
+            <a:pPr algn="ctr">
+              <a:defRPr sz="1600" b="1">
+                <a:solidFill>
+                  <a:srgbClr val="1E2761"/>
+                </a:solidFill>
+              </a:defRPr>
+            </a:pPr>
+            <a:r>
+              <a:t>BookshelfEntry</a:t>
+            </a:r>
+          </a:p>
+          <a:p>
+            <a:pPr>
+              <a:defRPr sz="1200">
+                <a:solidFill>
+                  <a:srgbClr val="272C34"/>
+                </a:solidFill>
+              </a:defRPr>
+            </a:pPr>
+            <a:r>
+              <a:t>Core entity</a:t>
+            </a:r>
+          </a:p>
+        </p:txBody>
+      </p:sp>
+      <p:sp>
+        <p:nvSpPr>
+          <p:cNvPr id="9" name="Rounded Rectangle 8"/>
+          <p:cNvSpPr/>
+          <p:nvPr/>
+        </p:nvSpPr>
+        <p:spPr>
+          <a:xfrm>
+            <a:off x="9601200" y="1828800"/>
+            <a:ext cx="1645920" cy="1097280"/>
+          </a:xfrm>
+          <a:prstGeom prst="roundRect">
+            <a:avLst/>
+          </a:prstGeom>
+          <a:solidFill>
+            <a:srgbClr val="E7E8D1"/>
+          </a:solidFill>
+          <a:ln>
+            <a:solidFill>
+              <a:srgbClr val="E7E8D1"/>
+            </a:solidFill>
+          </a:ln>
+        </p:spPr>
+        <p:style>
+          <a:lnRef idx="1">
+            <a:schemeClr val="accent1"/>
+          </a:lnRef>
+          <a:fillRef idx="3">
+            <a:schemeClr val="accent1"/>
+          </a:fillRef>
+          <a:effectRef idx="2">
+            <a:schemeClr val="accent1"/>
+          </a:effectRef>
+          <a:fontRef idx="minor">
+            <a:schemeClr val="lt1"/>
+          </a:fontRef>
+        </p:style>
+        <p:txBody>
+          <a:bodyPr rtlCol="0" anchor="ctr" wrap="square" lIns="164592" rIns="164592" tIns="128016" bIns="109728"/>
+          <a:lstStyle/>
+          <a:p>
+            <a:pPr algn="ctr">
+              <a:defRPr sz="1600" b="1">
+                <a:solidFill>
+                  <a:srgbClr val="1E2761"/>
+                </a:solidFill>
+              </a:defRPr>
+            </a:pPr>
+            <a:r>
+              <a:t>Review</a:t>
+            </a:r>
+          </a:p>
+          <a:p>
+            <a:pPr>
+              <a:defRPr sz="1200">
+                <a:solidFill>
+                  <a:srgbClr val="272C34"/>
+                </a:solidFill>
+              </a:defRPr>
+            </a:pPr>
+            <a:r>
+              <a:t>Core entity</a:t>
+            </a:r>
+          </a:p>
+        </p:txBody>
+      </p:sp>
+      <p:sp>
+        <p:nvSpPr>
+          <p:cNvPr id="10" name="TextBox 9"/>
+          <p:cNvSpPr txBox="1"/>
+          <p:nvPr/>
+        </p:nvSpPr>
+        <p:spPr>
+          <a:xfrm>
+            <a:off x="868680" y="3657600"/>
+            <a:ext cx="10332720" cy="1188720"/>
+          </a:xfrm>
+          <a:prstGeom prst="rect">
+            <a:avLst/>
+          </a:prstGeom>
+          <a:noFill/>
+        </p:spPr>
+        <p:txBody>
+          <a:bodyPr wrap="square" anchor="t" lIns="0" rIns="0" tIns="0" bIns="0">
+            <a:spAutoFit/>
+          </a:bodyPr>
+          <a:lstStyle/>
+          <a:p>
+            <a:pPr algn="l">
+              <a:defRPr sz="1800" b="0">
+                <a:solidFill>
+                  <a:srgbClr val="272C34"/>
+                </a:solidFill>
+              </a:defRPr>
+            </a:pPr>
+            <a:r>
+              <a:t>Many-to-many: Book to Author and Book to Genre. User-linked uniqueness rules: one bookshelf entry per user per book, and one review per user per book.</a:t>
+            </a:r>
+          </a:p>
+        </p:txBody>
+      </p:sp>
+      <p:sp>
+        <p:nvSpPr>
+          <p:cNvPr id="11" name="TextBox 10"/>
+          <p:cNvSpPr txBox="1"/>
+          <p:nvPr/>
+        </p:nvSpPr>
+        <p:spPr>
+          <a:xfrm>
+            <a:off x="868680" y="4572000"/>
+            <a:ext cx="10058400" cy="3566160"/>
           </a:xfrm>
           <a:prstGeom prst="rect">
             <a:avLst/>
@@ -3901,50 +6070,39 @@
           </a:bodyPr>
           <a:lstStyle/>
           <a:p>
-            <a:pPr algn="l">
-              <a:defRPr sz="1800">
+            <a:pPr>
+              <a:defRPr sz="1600">
                 <a:solidFill>
                   <a:srgbClr val="272C34"/>
                 </a:solidFill>
               </a:defRPr>
             </a:pPr>
             <a:r>
-              <a:t>Core entities are Author, Genre, Book, BookshelfEntry, and Review. The model supports many-to-many links for catalog metadata and user-specific constraints for bookshelf and review ownership.</a:t>
-            </a:r>
-          </a:p>
-        </p:txBody>
-      </p:sp>
-      <p:sp>
-        <p:nvSpPr>
-          <p:cNvPr id="5" name="TextBox 4"/>
-          <p:cNvSpPr txBox="1"/>
-          <p:nvPr/>
-        </p:nvSpPr>
-        <p:spPr>
-          <a:xfrm>
-            <a:off x="9966960" y="6217920"/>
-            <a:ext cx="1005840" cy="274320"/>
-          </a:xfrm>
-          <a:prstGeom prst="rect">
-            <a:avLst/>
-          </a:prstGeom>
-          <a:noFill/>
-        </p:spPr>
-        <p:txBody>
-          <a:bodyPr wrap="none">
-            <a:spAutoFit/>
-          </a:bodyPr>
-          <a:lstStyle/>
-          <a:p>
-            <a:pPr algn="r">
-              <a:defRPr sz="1000">
+              <a:t>Google metadata lands in catalog tables</a:t>
+            </a:r>
+          </a:p>
+          <a:p>
+            <a:pPr>
+              <a:defRPr sz="1600">
                 <a:solidFill>
                   <a:srgbClr val="272C34"/>
                 </a:solidFill>
               </a:defRPr>
             </a:pPr>
             <a:r>
-              <a:t>04</a:t>
+              <a:t>User behavior lands in bookshelf and review tables</a:t>
+            </a:r>
+          </a:p>
+          <a:p>
+            <a:pPr>
+              <a:defRPr sz="1600">
+                <a:solidFill>
+                  <a:srgbClr val="272C34"/>
+                </a:solidFill>
+              </a:defRPr>
+            </a:pPr>
+            <a:r>
+              <a:t>Analytics derive from both imported metadata and local activity</a:t>
             </a:r>
           </a:p>
         </p:txBody>
@@ -3963,7 +6121,7 @@
     <p:bg>
       <p:bgPr>
         <a:solidFill>
-          <a:srgbClr val="F5F6F0"/>
+          <a:srgbClr val="F7F4EA"/>
         </a:solidFill>
         <a:effectLst/>
       </p:bgPr>
@@ -3983,8 +6141,8 @@
         </p:nvSpPr>
         <p:spPr>
           <a:xfrm>
-            <a:off x="731520" y="548640"/>
-            <a:ext cx="10607040" cy="822960"/>
+            <a:off x="640080" y="411480"/>
+            <a:ext cx="8412480" cy="640080"/>
           </a:xfrm>
           <a:prstGeom prst="rect">
             <a:avLst/>
@@ -3992,12 +6150,12 @@
           <a:noFill/>
         </p:spPr>
         <p:txBody>
-          <a:bodyPr wrap="square">
+          <a:bodyPr wrap="square" anchor="t" lIns="0" rIns="0" tIns="0" bIns="0">
             <a:spAutoFit/>
           </a:bodyPr>
           <a:lstStyle/>
           <a:p>
-            <a:pPr>
+            <a:pPr algn="l">
               <a:defRPr sz="2800" b="1">
                 <a:solidFill>
                   <a:srgbClr val="272C34"/>
@@ -4018,14 +6176,14 @@
         </p:nvSpPr>
         <p:spPr>
           <a:xfrm>
-            <a:off x="731520" y="1554480"/>
-            <a:ext cx="1188720" cy="128016"/>
+            <a:off x="640080" y="1188720"/>
+            <a:ext cx="1325880" cy="109728"/>
           </a:xfrm>
           <a:prstGeom prst="rect">
             <a:avLst/>
           </a:prstGeom>
           <a:solidFill>
-            <a:srgbClr val="F96167"/>
+            <a:srgbClr val="065A82"/>
           </a:solidFill>
           <a:ln>
             <a:noFill/>
@@ -4061,8 +6219,8 @@
         </p:nvSpPr>
         <p:spPr>
           <a:xfrm>
-            <a:off x="868680" y="1874519"/>
-            <a:ext cx="10332720" cy="3566160"/>
+            <a:off x="10881360" y="384048"/>
+            <a:ext cx="548640" cy="274320"/>
           </a:xfrm>
           <a:prstGeom prst="rect">
             <a:avLst/>
@@ -4070,34 +6228,298 @@
           <a:noFill/>
         </p:spPr>
         <p:txBody>
-          <a:bodyPr wrap="square" lIns="0" rIns="0" tIns="0" bIns="0">
+          <a:bodyPr wrap="square" anchor="t" lIns="0" rIns="0" tIns="0" bIns="0">
             <a:spAutoFit/>
           </a:bodyPr>
           <a:lstStyle/>
           <a:p>
-            <a:pPr algn="l">
-              <a:defRPr sz="1800">
+            <a:pPr algn="r">
+              <a:defRPr sz="1000" b="0">
                 <a:solidFill>
                   <a:srgbClr val="272C34"/>
                 </a:solidFill>
               </a:defRPr>
             </a:pPr>
             <a:r>
-              <a:t>Metadata is fetched, normalized, and written into SQLite so the API remains database-driven. The ingestion pipeline handles authors, categories, ISBN values, publication dates, and missing fields.</a:t>
-            </a:r>
-          </a:p>
-        </p:txBody>
-      </p:sp>
-      <p:sp>
-        <p:nvSpPr>
-          <p:cNvPr id="5" name="TextBox 4"/>
+              <a:t>05</a:t>
+            </a:r>
+          </a:p>
+        </p:txBody>
+      </p:sp>
+      <p:sp>
+        <p:nvSpPr>
+          <p:cNvPr id="5" name="Rounded Rectangle 4"/>
+          <p:cNvSpPr/>
+          <p:nvPr/>
+        </p:nvSpPr>
+        <p:spPr>
+          <a:xfrm>
+            <a:off x="868680" y="1920240"/>
+            <a:ext cx="2331720" cy="1691640"/>
+          </a:xfrm>
+          <a:prstGeom prst="roundRect">
+            <a:avLst/>
+          </a:prstGeom>
+          <a:solidFill>
+            <a:srgbClr val="FFFFFF"/>
+          </a:solidFill>
+          <a:ln>
+            <a:solidFill>
+              <a:srgbClr val="FFFFFF"/>
+            </a:solidFill>
+          </a:ln>
+        </p:spPr>
+        <p:style>
+          <a:lnRef idx="1">
+            <a:schemeClr val="accent1"/>
+          </a:lnRef>
+          <a:fillRef idx="3">
+            <a:schemeClr val="accent1"/>
+          </a:fillRef>
+          <a:effectRef idx="2">
+            <a:schemeClr val="accent1"/>
+          </a:effectRef>
+          <a:fontRef idx="minor">
+            <a:schemeClr val="lt1"/>
+          </a:fontRef>
+        </p:style>
+        <p:txBody>
+          <a:bodyPr rtlCol="0" anchor="ctr" wrap="square" lIns="164592" rIns="164592" tIns="128016" bIns="109728"/>
+          <a:lstStyle/>
+          <a:p>
+            <a:pPr algn="ctr">
+              <a:defRPr sz="1600" b="1">
+                <a:solidFill>
+                  <a:srgbClr val="1E2761"/>
+                </a:solidFill>
+              </a:defRPr>
+            </a:pPr>
+            <a:r>
+              <a:t>1. Fetch</a:t>
+            </a:r>
+          </a:p>
+          <a:p>
+            <a:pPr>
+              <a:defRPr sz="1200">
+                <a:solidFill>
+                  <a:srgbClr val="272C34"/>
+                </a:solidFill>
+              </a:defRPr>
+            </a:pPr>
+            <a:r>
+              <a:t>Read Google Books payloads or local sample files</a:t>
+            </a:r>
+          </a:p>
+        </p:txBody>
+      </p:sp>
+      <p:sp>
+        <p:nvSpPr>
+          <p:cNvPr id="6" name="Rounded Rectangle 5"/>
+          <p:cNvSpPr/>
+          <p:nvPr/>
+        </p:nvSpPr>
+        <p:spPr>
+          <a:xfrm>
+            <a:off x="3611880" y="1920240"/>
+            <a:ext cx="2331720" cy="1691640"/>
+          </a:xfrm>
+          <a:prstGeom prst="roundRect">
+            <a:avLst/>
+          </a:prstGeom>
+          <a:solidFill>
+            <a:srgbClr val="FFFFFF"/>
+          </a:solidFill>
+          <a:ln>
+            <a:solidFill>
+              <a:srgbClr val="FFFFFF"/>
+            </a:solidFill>
+          </a:ln>
+        </p:spPr>
+        <p:style>
+          <a:lnRef idx="1">
+            <a:schemeClr val="accent1"/>
+          </a:lnRef>
+          <a:fillRef idx="3">
+            <a:schemeClr val="accent1"/>
+          </a:fillRef>
+          <a:effectRef idx="2">
+            <a:schemeClr val="accent1"/>
+          </a:effectRef>
+          <a:fontRef idx="minor">
+            <a:schemeClr val="lt1"/>
+          </a:fontRef>
+        </p:style>
+        <p:txBody>
+          <a:bodyPr rtlCol="0" anchor="ctr" wrap="square" lIns="164592" rIns="164592" tIns="128016" bIns="109728"/>
+          <a:lstStyle/>
+          <a:p>
+            <a:pPr algn="ctr">
+              <a:defRPr sz="1600" b="1">
+                <a:solidFill>
+                  <a:srgbClr val="1E2761"/>
+                </a:solidFill>
+              </a:defRPr>
+            </a:pPr>
+            <a:r>
+              <a:t>2. Normalize</a:t>
+            </a:r>
+          </a:p>
+          <a:p>
+            <a:pPr>
+              <a:defRPr sz="1200">
+                <a:solidFill>
+                  <a:srgbClr val="272C34"/>
+                </a:solidFill>
+              </a:defRPr>
+            </a:pPr>
+            <a:r>
+              <a:t>Extract titles, authors, categories, ISBNs, dates, and links</a:t>
+            </a:r>
+          </a:p>
+        </p:txBody>
+      </p:sp>
+      <p:sp>
+        <p:nvSpPr>
+          <p:cNvPr id="7" name="Rounded Rectangle 6"/>
+          <p:cNvSpPr/>
+          <p:nvPr/>
+        </p:nvSpPr>
+        <p:spPr>
+          <a:xfrm>
+            <a:off x="6355080" y="1920240"/>
+            <a:ext cx="2331720" cy="1691640"/>
+          </a:xfrm>
+          <a:prstGeom prst="roundRect">
+            <a:avLst/>
+          </a:prstGeom>
+          <a:solidFill>
+            <a:srgbClr val="FFFFFF"/>
+          </a:solidFill>
+          <a:ln>
+            <a:solidFill>
+              <a:srgbClr val="FFFFFF"/>
+            </a:solidFill>
+          </a:ln>
+        </p:spPr>
+        <p:style>
+          <a:lnRef idx="1">
+            <a:schemeClr val="accent1"/>
+          </a:lnRef>
+          <a:fillRef idx="3">
+            <a:schemeClr val="accent1"/>
+          </a:fillRef>
+          <a:effectRef idx="2">
+            <a:schemeClr val="accent1"/>
+          </a:effectRef>
+          <a:fontRef idx="minor">
+            <a:schemeClr val="lt1"/>
+          </a:fontRef>
+        </p:style>
+        <p:txBody>
+          <a:bodyPr rtlCol="0" anchor="ctr" wrap="square" lIns="164592" rIns="164592" tIns="128016" bIns="109728"/>
+          <a:lstStyle/>
+          <a:p>
+            <a:pPr algn="ctr">
+              <a:defRPr sz="1600" b="1">
+                <a:solidFill>
+                  <a:srgbClr val="1E2761"/>
+                </a:solidFill>
+              </a:defRPr>
+            </a:pPr>
+            <a:r>
+              <a:t>3. Persist</a:t>
+            </a:r>
+          </a:p>
+          <a:p>
+            <a:pPr>
+              <a:defRPr sz="1200">
+                <a:solidFill>
+                  <a:srgbClr val="272C34"/>
+                </a:solidFill>
+              </a:defRPr>
+            </a:pPr>
+            <a:r>
+              <a:t>Create or update local authors, genres, and books</a:t>
+            </a:r>
+          </a:p>
+        </p:txBody>
+      </p:sp>
+      <p:sp>
+        <p:nvSpPr>
+          <p:cNvPr id="8" name="Rounded Rectangle 7"/>
+          <p:cNvSpPr/>
+          <p:nvPr/>
+        </p:nvSpPr>
+        <p:spPr>
+          <a:xfrm>
+            <a:off x="9098280" y="1920240"/>
+            <a:ext cx="2331720" cy="1691640"/>
+          </a:xfrm>
+          <a:prstGeom prst="roundRect">
+            <a:avLst/>
+          </a:prstGeom>
+          <a:solidFill>
+            <a:srgbClr val="FFFFFF"/>
+          </a:solidFill>
+          <a:ln>
+            <a:solidFill>
+              <a:srgbClr val="FFFFFF"/>
+            </a:solidFill>
+          </a:ln>
+        </p:spPr>
+        <p:style>
+          <a:lnRef idx="1">
+            <a:schemeClr val="accent1"/>
+          </a:lnRef>
+          <a:fillRef idx="3">
+            <a:schemeClr val="accent1"/>
+          </a:fillRef>
+          <a:effectRef idx="2">
+            <a:schemeClr val="accent1"/>
+          </a:effectRef>
+          <a:fontRef idx="minor">
+            <a:schemeClr val="lt1"/>
+          </a:fontRef>
+        </p:style>
+        <p:txBody>
+          <a:bodyPr rtlCol="0" anchor="ctr" wrap="square" lIns="164592" rIns="164592" tIns="128016" bIns="109728"/>
+          <a:lstStyle/>
+          <a:p>
+            <a:pPr algn="ctr">
+              <a:defRPr sz="1600" b="1">
+                <a:solidFill>
+                  <a:srgbClr val="1E2761"/>
+                </a:solidFill>
+              </a:defRPr>
+            </a:pPr>
+            <a:r>
+              <a:t>4. Build on local data</a:t>
+            </a:r>
+          </a:p>
+          <a:p>
+            <a:pPr>
+              <a:defRPr sz="1200">
+                <a:solidFill>
+                  <a:srgbClr val="272C34"/>
+                </a:solidFill>
+              </a:defRPr>
+            </a:pPr>
+            <a:r>
+              <a:t>Run CRUD, recommendation, and analytics from SQLite</a:t>
+            </a:r>
+          </a:p>
+        </p:txBody>
+      </p:sp>
+      <p:sp>
+        <p:nvSpPr>
+          <p:cNvPr id="9" name="TextBox 8"/>
           <p:cNvSpPr txBox="1"/>
           <p:nvPr/>
         </p:nvSpPr>
         <p:spPr>
           <a:xfrm>
-            <a:off x="9966960" y="6217920"/>
-            <a:ext cx="1005840" cy="274320"/>
+            <a:off x="868680" y="4206240"/>
+            <a:ext cx="10241280" cy="1097280"/>
           </a:xfrm>
           <a:prstGeom prst="rect">
             <a:avLst/>
@@ -4105,20 +6527,20 @@
           <a:noFill/>
         </p:spPr>
         <p:txBody>
-          <a:bodyPr wrap="none">
+          <a:bodyPr wrap="square" anchor="t" lIns="0" rIns="0" tIns="0" bIns="0">
             <a:spAutoFit/>
           </a:bodyPr>
           <a:lstStyle/>
           <a:p>
-            <a:pPr algn="r">
-              <a:defRPr sz="1000">
+            <a:pPr algn="l">
+              <a:defRPr sz="1800" b="0">
                 <a:solidFill>
                   <a:srgbClr val="272C34"/>
                 </a:solidFill>
               </a:defRPr>
             </a:pPr>
             <a:r>
-              <a:t>05</a:t>
+              <a:t>This keeps the runtime API database-driven and reproducible instead of depending on live external responses during marking.</a:t>
             </a:r>
           </a:p>
         </p:txBody>
@@ -4137,7 +6559,7 @@
     <p:bg>
       <p:bgPr>
         <a:solidFill>
-          <a:srgbClr val="F5F6F0"/>
+          <a:srgbClr val="F7F4EA"/>
         </a:solidFill>
         <a:effectLst/>
       </p:bgPr>
@@ -4157,8 +6579,8 @@
         </p:nvSpPr>
         <p:spPr>
           <a:xfrm>
-            <a:off x="731520" y="548640"/>
-            <a:ext cx="10607040" cy="822960"/>
+            <a:off x="640080" y="411480"/>
+            <a:ext cx="8412480" cy="640080"/>
           </a:xfrm>
           <a:prstGeom prst="rect">
             <a:avLst/>
@@ -4166,12 +6588,12 @@
           <a:noFill/>
         </p:spPr>
         <p:txBody>
-          <a:bodyPr wrap="square">
+          <a:bodyPr wrap="square" anchor="t" lIns="0" rIns="0" tIns="0" bIns="0">
             <a:spAutoFit/>
           </a:bodyPr>
           <a:lstStyle/>
           <a:p>
-            <a:pPr>
+            <a:pPr algn="l">
               <a:defRPr sz="2800" b="1">
                 <a:solidFill>
                   <a:srgbClr val="272C34"/>
@@ -4179,7 +6601,7 @@
               </a:defRPr>
             </a:pPr>
             <a:r>
-              <a:t>Core API Capabilities</a:t>
+              <a:t>API Documentation and Endpoints</a:t>
             </a:r>
           </a:p>
         </p:txBody>
@@ -4192,14 +6614,14 @@
         </p:nvSpPr>
         <p:spPr>
           <a:xfrm>
-            <a:off x="731520" y="1554480"/>
-            <a:ext cx="1188720" cy="128016"/>
+            <a:off x="640080" y="1188720"/>
+            <a:ext cx="1325880" cy="109728"/>
           </a:xfrm>
           <a:prstGeom prst="rect">
             <a:avLst/>
           </a:prstGeom>
           <a:solidFill>
-            <a:srgbClr val="065A82"/>
+            <a:srgbClr val="F96167"/>
           </a:solidFill>
           <a:ln>
             <a:noFill/>
@@ -4235,8 +6657,43 @@
         </p:nvSpPr>
         <p:spPr>
           <a:xfrm>
-            <a:off x="868680" y="1874519"/>
-            <a:ext cx="10332720" cy="3566160"/>
+            <a:off x="10881360" y="384048"/>
+            <a:ext cx="548640" cy="274320"/>
+          </a:xfrm>
+          <a:prstGeom prst="rect">
+            <a:avLst/>
+          </a:prstGeom>
+          <a:noFill/>
+        </p:spPr>
+        <p:txBody>
+          <a:bodyPr wrap="square" anchor="t" lIns="0" rIns="0" tIns="0" bIns="0">
+            <a:spAutoFit/>
+          </a:bodyPr>
+          <a:lstStyle/>
+          <a:p>
+            <a:pPr algn="r">
+              <a:defRPr sz="1000" b="0">
+                <a:solidFill>
+                  <a:srgbClr val="272C34"/>
+                </a:solidFill>
+              </a:defRPr>
+            </a:pPr>
+            <a:r>
+              <a:t>06</a:t>
+            </a:r>
+          </a:p>
+        </p:txBody>
+      </p:sp>
+      <p:sp>
+        <p:nvSpPr>
+          <p:cNvPr id="5" name="TextBox 4"/>
+          <p:cNvSpPr txBox="1"/>
+          <p:nvPr/>
+        </p:nvSpPr>
+        <p:spPr>
+          <a:xfrm>
+            <a:off x="868680" y="1783080"/>
+            <a:ext cx="5394960" cy="3566160"/>
           </a:xfrm>
           <a:prstGeom prst="rect">
             <a:avLst/>
@@ -4249,50 +6706,207 @@
           </a:bodyPr>
           <a:lstStyle/>
           <a:p>
-            <a:pPr algn="l">
-              <a:defRPr sz="1800">
+            <a:pPr>
+              <a:defRPr sz="1700">
                 <a:solidFill>
                   <a:srgbClr val="272C34"/>
                 </a:solidFill>
               </a:defRPr>
             </a:pPr>
             <a:r>
-              <a:t>The API supports authentication, catalog browsing and management, personal bookshelf CRUD, review CRUD, and machine-readable documentation generation.</a:t>
-            </a:r>
-          </a:p>
-        </p:txBody>
-      </p:sp>
-      <p:sp>
-        <p:nvSpPr>
-          <p:cNvPr id="5" name="TextBox 4"/>
-          <p:cNvSpPr txBox="1"/>
-          <p:nvPr/>
-        </p:nvSpPr>
-        <p:spPr>
-          <a:xfrm>
-            <a:off x="9966960" y="6217920"/>
-            <a:ext cx="1005840" cy="274320"/>
-          </a:xfrm>
-          <a:prstGeom prst="rect">
-            <a:avLst/>
-          </a:prstGeom>
-          <a:noFill/>
-        </p:spPr>
-        <p:txBody>
-          <a:bodyPr wrap="none">
-            <a:spAutoFit/>
-          </a:bodyPr>
-          <a:lstStyle/>
-          <a:p>
-            <a:pPr algn="r">
-              <a:defRPr sz="1000">
+              <a:t>Health, schema, and Swagger UI endpoints</a:t>
+            </a:r>
+          </a:p>
+          <a:p>
+            <a:pPr>
+              <a:defRPr sz="1700">
                 <a:solidFill>
                   <a:srgbClr val="272C34"/>
                 </a:solidFill>
               </a:defRPr>
             </a:pPr>
             <a:r>
-              <a:t>06</a:t>
+              <a:t>Authentication endpoints for register, token, refresh, and current user</a:t>
+            </a:r>
+          </a:p>
+          <a:p>
+            <a:pPr>
+              <a:defRPr sz="1700">
+                <a:solidFill>
+                  <a:srgbClr val="272C34"/>
+                </a:solidFill>
+              </a:defRPr>
+            </a:pPr>
+            <a:r>
+              <a:t>Catalog CRUD for books, authors, and genres</a:t>
+            </a:r>
+          </a:p>
+          <a:p>
+            <a:pPr>
+              <a:defRPr sz="1700">
+                <a:solidFill>
+                  <a:srgbClr val="272C34"/>
+                </a:solidFill>
+              </a:defRPr>
+            </a:pPr>
+            <a:r>
+              <a:t>Bookshelf and review workflows</a:t>
+            </a:r>
+          </a:p>
+          <a:p>
+            <a:pPr>
+              <a:defRPr sz="1700">
+                <a:solidFill>
+                  <a:srgbClr val="272C34"/>
+                </a:solidFill>
+              </a:defRPr>
+            </a:pPr>
+            <a:r>
+              <a:t>Recommendation and analytics endpoints</a:t>
+            </a:r>
+          </a:p>
+        </p:txBody>
+      </p:sp>
+      <p:sp>
+        <p:nvSpPr>
+          <p:cNvPr id="6" name="Rounded Rectangle 5"/>
+          <p:cNvSpPr/>
+          <p:nvPr/>
+        </p:nvSpPr>
+        <p:spPr>
+          <a:xfrm>
+            <a:off x="6583680" y="1783080"/>
+            <a:ext cx="4617720" cy="1828800"/>
+          </a:xfrm>
+          <a:prstGeom prst="roundRect">
+            <a:avLst/>
+          </a:prstGeom>
+          <a:solidFill>
+            <a:srgbClr val="FFFFFF"/>
+          </a:solidFill>
+          <a:ln>
+            <a:solidFill>
+              <a:srgbClr val="FFFFFF"/>
+            </a:solidFill>
+          </a:ln>
+        </p:spPr>
+        <p:style>
+          <a:lnRef idx="1">
+            <a:schemeClr val="accent1"/>
+          </a:lnRef>
+          <a:fillRef idx="3">
+            <a:schemeClr val="accent1"/>
+          </a:fillRef>
+          <a:effectRef idx="2">
+            <a:schemeClr val="accent1"/>
+          </a:effectRef>
+          <a:fontRef idx="minor">
+            <a:schemeClr val="lt1"/>
+          </a:fontRef>
+        </p:style>
+        <p:txBody>
+          <a:bodyPr rtlCol="0" anchor="ctr" wrap="square" lIns="164592" rIns="164592" tIns="128016" bIns="109728"/>
+          <a:lstStyle/>
+          <a:p>
+            <a:pPr algn="ctr">
+              <a:defRPr sz="1600" b="1">
+                <a:solidFill>
+                  <a:srgbClr val="1E2761"/>
+                </a:solidFill>
+              </a:defRPr>
+            </a:pPr>
+            <a:r>
+              <a:t>Submission docs</a:t>
+            </a:r>
+          </a:p>
+          <a:p>
+            <a:pPr>
+              <a:defRPr sz="1200">
+                <a:solidFill>
+                  <a:srgbClr val="272C34"/>
+                </a:solidFill>
+              </a:defRPr>
+            </a:pPr>
+            <a:r>
+              <a:t>OpenAPI YAML</a:t>
+            </a:r>
+            <a:br/>
+            <a:r>
+              <a:t>API documentation PDF</a:t>
+            </a:r>
+            <a:br/>
+            <a:r>
+              <a:t>Technical report PDF</a:t>
+            </a:r>
+            <a:br/>
+            <a:r>
+              <a:t>Slides PPTX</a:t>
+            </a:r>
+          </a:p>
+        </p:txBody>
+      </p:sp>
+      <p:sp>
+        <p:nvSpPr>
+          <p:cNvPr id="7" name="Rounded Rectangle 6"/>
+          <p:cNvSpPr/>
+          <p:nvPr/>
+        </p:nvSpPr>
+        <p:spPr>
+          <a:xfrm>
+            <a:off x="6583680" y="3931920"/>
+            <a:ext cx="4617720" cy="1371600"/>
+          </a:xfrm>
+          <a:prstGeom prst="roundRect">
+            <a:avLst/>
+          </a:prstGeom>
+          <a:solidFill>
+            <a:srgbClr val="E7E8D1"/>
+          </a:solidFill>
+          <a:ln>
+            <a:solidFill>
+              <a:srgbClr val="E7E8D1"/>
+            </a:solidFill>
+          </a:ln>
+        </p:spPr>
+        <p:style>
+          <a:lnRef idx="1">
+            <a:schemeClr val="accent1"/>
+          </a:lnRef>
+          <a:fillRef idx="3">
+            <a:schemeClr val="accent1"/>
+          </a:fillRef>
+          <a:effectRef idx="2">
+            <a:schemeClr val="accent1"/>
+          </a:effectRef>
+          <a:fontRef idx="minor">
+            <a:schemeClr val="lt1"/>
+          </a:fontRef>
+        </p:style>
+        <p:txBody>
+          <a:bodyPr rtlCol="0" anchor="ctr" wrap="square" lIns="164592" rIns="164592" tIns="128016" bIns="109728"/>
+          <a:lstStyle/>
+          <a:p>
+            <a:pPr algn="ctr">
+              <a:defRPr sz="1600" b="1">
+                <a:solidFill>
+                  <a:srgbClr val="1E2761"/>
+                </a:solidFill>
+              </a:defRPr>
+            </a:pPr>
+            <a:r>
+              <a:t>Permissions</a:t>
+            </a:r>
+          </a:p>
+          <a:p>
+            <a:pPr>
+              <a:defRPr sz="1200">
+                <a:solidFill>
+                  <a:srgbClr val="272C34"/>
+                </a:solidFill>
+              </a:defRPr>
+            </a:pPr>
+            <a:r>
+              <a:t>Public read for catalog and selected analytics. Staff-only catalog writes. Authenticated user ownership for bookshelf and reviews.</a:t>
             </a:r>
           </a:p>
         </p:txBody>
@@ -4311,7 +6925,7 @@
     <p:bg>
       <p:bgPr>
         <a:solidFill>
-          <a:srgbClr val="F5F6F0"/>
+          <a:srgbClr val="F7F4EA"/>
         </a:solidFill>
         <a:effectLst/>
       </p:bgPr>
@@ -4331,8 +6945,8 @@
         </p:nvSpPr>
         <p:spPr>
           <a:xfrm>
-            <a:off x="731520" y="548640"/>
-            <a:ext cx="10607040" cy="822960"/>
+            <a:off x="640080" y="411480"/>
+            <a:ext cx="8412480" cy="640080"/>
           </a:xfrm>
           <a:prstGeom prst="rect">
             <a:avLst/>
@@ -4340,12 +6954,12 @@
           <a:noFill/>
         </p:spPr>
         <p:txBody>
-          <a:bodyPr wrap="square">
+          <a:bodyPr wrap="square" anchor="t" lIns="0" rIns="0" tIns="0" bIns="0">
             <a:spAutoFit/>
           </a:bodyPr>
           <a:lstStyle/>
           <a:p>
-            <a:pPr>
+            <a:pPr algn="l">
               <a:defRPr sz="2800" b="1">
                 <a:solidFill>
                   <a:srgbClr val="272C34"/>
@@ -4366,14 +6980,14 @@
         </p:nvSpPr>
         <p:spPr>
           <a:xfrm>
-            <a:off x="731520" y="1554480"/>
-            <a:ext cx="1188720" cy="128016"/>
+            <a:off x="640080" y="1188720"/>
+            <a:ext cx="1325880" cy="109728"/>
           </a:xfrm>
           <a:prstGeom prst="rect">
             <a:avLst/>
           </a:prstGeom>
           <a:solidFill>
-            <a:srgbClr val="F96167"/>
+            <a:srgbClr val="065A82"/>
           </a:solidFill>
           <a:ln>
             <a:noFill/>
@@ -4409,8 +7023,307 @@
         </p:nvSpPr>
         <p:spPr>
           <a:xfrm>
-            <a:off x="868680" y="1874519"/>
-            <a:ext cx="10332720" cy="3566160"/>
+            <a:off x="10881360" y="384048"/>
+            <a:ext cx="548640" cy="274320"/>
+          </a:xfrm>
+          <a:prstGeom prst="rect">
+            <a:avLst/>
+          </a:prstGeom>
+          <a:noFill/>
+        </p:spPr>
+        <p:txBody>
+          <a:bodyPr wrap="square" anchor="t" lIns="0" rIns="0" tIns="0" bIns="0">
+            <a:spAutoFit/>
+          </a:bodyPr>
+          <a:lstStyle/>
+          <a:p>
+            <a:pPr algn="r">
+              <a:defRPr sz="1000" b="0">
+                <a:solidFill>
+                  <a:srgbClr val="272C34"/>
+                </a:solidFill>
+              </a:defRPr>
+            </a:pPr>
+            <a:r>
+              <a:t>07</a:t>
+            </a:r>
+          </a:p>
+        </p:txBody>
+      </p:sp>
+      <p:sp>
+        <p:nvSpPr>
+          <p:cNvPr id="5" name="Rounded Rectangle 4"/>
+          <p:cNvSpPr/>
+          <p:nvPr/>
+        </p:nvSpPr>
+        <p:spPr>
+          <a:xfrm>
+            <a:off x="868680" y="1783080"/>
+            <a:ext cx="2377440" cy="1508760"/>
+          </a:xfrm>
+          <a:prstGeom prst="roundRect">
+            <a:avLst/>
+          </a:prstGeom>
+          <a:solidFill>
+            <a:srgbClr val="FFFFFF"/>
+          </a:solidFill>
+          <a:ln>
+            <a:solidFill>
+              <a:srgbClr val="FFFFFF"/>
+            </a:solidFill>
+          </a:ln>
+        </p:spPr>
+        <p:style>
+          <a:lnRef idx="1">
+            <a:schemeClr val="accent1"/>
+          </a:lnRef>
+          <a:fillRef idx="3">
+            <a:schemeClr val="accent1"/>
+          </a:fillRef>
+          <a:effectRef idx="2">
+            <a:schemeClr val="accent1"/>
+          </a:effectRef>
+          <a:fontRef idx="minor">
+            <a:schemeClr val="lt1"/>
+          </a:fontRef>
+        </p:style>
+        <p:txBody>
+          <a:bodyPr rtlCol="0" anchor="ctr" wrap="square" lIns="164592" rIns="164592" tIns="128016" bIns="109728"/>
+          <a:lstStyle/>
+          <a:p>
+            <a:pPr algn="ctr">
+              <a:defRPr sz="1600" b="1">
+                <a:solidFill>
+                  <a:srgbClr val="1E2761"/>
+                </a:solidFill>
+              </a:defRPr>
+            </a:pPr>
+            <a:r>
+              <a:t>Signal 1</a:t>
+            </a:r>
+          </a:p>
+          <a:p>
+            <a:pPr>
+              <a:defRPr sz="1200">
+                <a:solidFill>
+                  <a:srgbClr val="272C34"/>
+                </a:solidFill>
+              </a:defRPr>
+            </a:pPr>
+            <a:r>
+              <a:t>Preferred genres from highly rated books</a:t>
+            </a:r>
+          </a:p>
+        </p:txBody>
+      </p:sp>
+      <p:sp>
+        <p:nvSpPr>
+          <p:cNvPr id="6" name="Rounded Rectangle 5"/>
+          <p:cNvSpPr/>
+          <p:nvPr/>
+        </p:nvSpPr>
+        <p:spPr>
+          <a:xfrm>
+            <a:off x="3429000" y="1783080"/>
+            <a:ext cx="2377440" cy="1508760"/>
+          </a:xfrm>
+          <a:prstGeom prst="roundRect">
+            <a:avLst/>
+          </a:prstGeom>
+          <a:solidFill>
+            <a:srgbClr val="FFFFFF"/>
+          </a:solidFill>
+          <a:ln>
+            <a:solidFill>
+              <a:srgbClr val="FFFFFF"/>
+            </a:solidFill>
+          </a:ln>
+        </p:spPr>
+        <p:style>
+          <a:lnRef idx="1">
+            <a:schemeClr val="accent1"/>
+          </a:lnRef>
+          <a:fillRef idx="3">
+            <a:schemeClr val="accent1"/>
+          </a:fillRef>
+          <a:effectRef idx="2">
+            <a:schemeClr val="accent1"/>
+          </a:effectRef>
+          <a:fontRef idx="minor">
+            <a:schemeClr val="lt1"/>
+          </a:fontRef>
+        </p:style>
+        <p:txBody>
+          <a:bodyPr rtlCol="0" anchor="ctr" wrap="square" lIns="164592" rIns="164592" tIns="128016" bIns="109728"/>
+          <a:lstStyle/>
+          <a:p>
+            <a:pPr algn="ctr">
+              <a:defRPr sz="1600" b="1">
+                <a:solidFill>
+                  <a:srgbClr val="1E2761"/>
+                </a:solidFill>
+              </a:defRPr>
+            </a:pPr>
+            <a:r>
+              <a:t>Signal 2</a:t>
+            </a:r>
+          </a:p>
+          <a:p>
+            <a:pPr>
+              <a:defRPr sz="1200">
+                <a:solidFill>
+                  <a:srgbClr val="272C34"/>
+                </a:solidFill>
+              </a:defRPr>
+            </a:pPr>
+            <a:r>
+              <a:t>Preferred authors from highly rated books</a:t>
+            </a:r>
+          </a:p>
+        </p:txBody>
+      </p:sp>
+      <p:sp>
+        <p:nvSpPr>
+          <p:cNvPr id="7" name="Rounded Rectangle 6"/>
+          <p:cNvSpPr/>
+          <p:nvPr/>
+        </p:nvSpPr>
+        <p:spPr>
+          <a:xfrm>
+            <a:off x="5989320" y="1783080"/>
+            <a:ext cx="2377440" cy="1508760"/>
+          </a:xfrm>
+          <a:prstGeom prst="roundRect">
+            <a:avLst/>
+          </a:prstGeom>
+          <a:solidFill>
+            <a:srgbClr val="FFFFFF"/>
+          </a:solidFill>
+          <a:ln>
+            <a:solidFill>
+              <a:srgbClr val="FFFFFF"/>
+            </a:solidFill>
+          </a:ln>
+        </p:spPr>
+        <p:style>
+          <a:lnRef idx="1">
+            <a:schemeClr val="accent1"/>
+          </a:lnRef>
+          <a:fillRef idx="3">
+            <a:schemeClr val="accent1"/>
+          </a:fillRef>
+          <a:effectRef idx="2">
+            <a:schemeClr val="accent1"/>
+          </a:effectRef>
+          <a:fontRef idx="minor">
+            <a:schemeClr val="lt1"/>
+          </a:fontRef>
+        </p:style>
+        <p:txBody>
+          <a:bodyPr rtlCol="0" anchor="ctr" wrap="square" lIns="164592" rIns="164592" tIns="128016" bIns="109728"/>
+          <a:lstStyle/>
+          <a:p>
+            <a:pPr algn="ctr">
+              <a:defRPr sz="1600" b="1">
+                <a:solidFill>
+                  <a:srgbClr val="1E2761"/>
+                </a:solidFill>
+              </a:defRPr>
+            </a:pPr>
+            <a:r>
+              <a:t>Signal 3</a:t>
+            </a:r>
+          </a:p>
+          <a:p>
+            <a:pPr>
+              <a:defRPr sz="1200">
+                <a:solidFill>
+                  <a:srgbClr val="272C34"/>
+                </a:solidFill>
+              </a:defRPr>
+            </a:pPr>
+            <a:r>
+              <a:t>External rating strength and count</a:t>
+            </a:r>
+          </a:p>
+        </p:txBody>
+      </p:sp>
+      <p:sp>
+        <p:nvSpPr>
+          <p:cNvPr id="8" name="Rounded Rectangle 7"/>
+          <p:cNvSpPr/>
+          <p:nvPr/>
+        </p:nvSpPr>
+        <p:spPr>
+          <a:xfrm>
+            <a:off x="8549640" y="1783080"/>
+            <a:ext cx="2377440" cy="1508760"/>
+          </a:xfrm>
+          <a:prstGeom prst="roundRect">
+            <a:avLst/>
+          </a:prstGeom>
+          <a:solidFill>
+            <a:srgbClr val="FFFFFF"/>
+          </a:solidFill>
+          <a:ln>
+            <a:solidFill>
+              <a:srgbClr val="FFFFFF"/>
+            </a:solidFill>
+          </a:ln>
+        </p:spPr>
+        <p:style>
+          <a:lnRef idx="1">
+            <a:schemeClr val="accent1"/>
+          </a:lnRef>
+          <a:fillRef idx="3">
+            <a:schemeClr val="accent1"/>
+          </a:fillRef>
+          <a:effectRef idx="2">
+            <a:schemeClr val="accent1"/>
+          </a:effectRef>
+          <a:fontRef idx="minor">
+            <a:schemeClr val="lt1"/>
+          </a:fontRef>
+        </p:style>
+        <p:txBody>
+          <a:bodyPr rtlCol="0" anchor="ctr" wrap="square" lIns="164592" rIns="164592" tIns="128016" bIns="109728"/>
+          <a:lstStyle/>
+          <a:p>
+            <a:pPr algn="ctr">
+              <a:defRPr sz="1600" b="1">
+                <a:solidFill>
+                  <a:srgbClr val="1E2761"/>
+                </a:solidFill>
+              </a:defRPr>
+            </a:pPr>
+            <a:r>
+              <a:t>Signal 4</a:t>
+            </a:r>
+          </a:p>
+          <a:p>
+            <a:pPr>
+              <a:defRPr sz="1200">
+                <a:solidFill>
+                  <a:srgbClr val="272C34"/>
+                </a:solidFill>
+              </a:defRPr>
+            </a:pPr>
+            <a:r>
+              <a:t>Local popularity from bookshelf and review activity</a:t>
+            </a:r>
+          </a:p>
+        </p:txBody>
+      </p:sp>
+      <p:sp>
+        <p:nvSpPr>
+          <p:cNvPr id="9" name="TextBox 8"/>
+          <p:cNvSpPr txBox="1"/>
+          <p:nvPr/>
+        </p:nvSpPr>
+        <p:spPr>
+          <a:xfrm>
+            <a:off x="868680" y="3794760"/>
+            <a:ext cx="10149840" cy="3566160"/>
           </a:xfrm>
           <a:prstGeom prst="rect">
             <a:avLst/>
@@ -4423,50 +7336,39 @@
           </a:bodyPr>
           <a:lstStyle/>
           <a:p>
-            <a:pPr algn="l">
-              <a:defRPr sz="1800">
+            <a:pPr>
+              <a:defRPr sz="1700">
                 <a:solidFill>
                   <a:srgbClr val="272C34"/>
                 </a:solidFill>
               </a:defRPr>
             </a:pPr>
             <a:r>
-              <a:t>Recommendations are rule-based and explainable, combining genre affinity, author affinity, external rating quality, and local popularity. Analytics expose genre popularity, reading summary, rating distribution, and top authors.</a:t>
-            </a:r>
-          </a:p>
-        </p:txBody>
-      </p:sp>
-      <p:sp>
-        <p:nvSpPr>
-          <p:cNvPr id="5" name="TextBox 4"/>
-          <p:cNvSpPr txBox="1"/>
-          <p:nvPr/>
-        </p:nvSpPr>
-        <p:spPr>
-          <a:xfrm>
-            <a:off x="9966960" y="6217920"/>
-            <a:ext cx="1005840" cy="274320"/>
-          </a:xfrm>
-          <a:prstGeom prst="rect">
-            <a:avLst/>
-          </a:prstGeom>
-          <a:noFill/>
-        </p:spPr>
-        <p:txBody>
-          <a:bodyPr wrap="none">
-            <a:spAutoFit/>
-          </a:bodyPr>
-          <a:lstStyle/>
-          <a:p>
-            <a:pPr algn="r">
-              <a:defRPr sz="1000">
+              <a:t>Recommendations exclude books already on the user's shelf or review history</a:t>
+            </a:r>
+          </a:p>
+          <a:p>
+            <a:pPr>
+              <a:defRPr sz="1700">
                 <a:solidFill>
                   <a:srgbClr val="272C34"/>
                 </a:solidFill>
               </a:defRPr>
             </a:pPr>
             <a:r>
-              <a:t>07</a:t>
+              <a:t>Analytics cover trending books, genre popularity, rating distribution, reading summary, and top authors</a:t>
+            </a:r>
+          </a:p>
+          <a:p>
+            <a:pPr>
+              <a:defRPr sz="1700">
+                <a:solidFill>
+                  <a:srgbClr val="272C34"/>
+                </a:solidFill>
+              </a:defRPr>
+            </a:pPr>
+            <a:r>
+              <a:t>The logic is intentionally explainable for easier testing and oral defence</a:t>
             </a:r>
           </a:p>
         </p:txBody>
@@ -4485,7 +7387,7 @@
     <p:bg>
       <p:bgPr>
         <a:solidFill>
-          <a:srgbClr val="F5F6F0"/>
+          <a:srgbClr val="F7F4EA"/>
         </a:solidFill>
         <a:effectLst/>
       </p:bgPr>
@@ -4505,8 +7407,8 @@
         </p:nvSpPr>
         <p:spPr>
           <a:xfrm>
-            <a:off x="731520" y="548640"/>
-            <a:ext cx="10607040" cy="822960"/>
+            <a:off x="640080" y="411480"/>
+            <a:ext cx="8412480" cy="640080"/>
           </a:xfrm>
           <a:prstGeom prst="rect">
             <a:avLst/>
@@ -4514,12 +7416,12 @@
           <a:noFill/>
         </p:spPr>
         <p:txBody>
-          <a:bodyPr wrap="square">
+          <a:bodyPr wrap="square" anchor="t" lIns="0" rIns="0" tIns="0" bIns="0">
             <a:spAutoFit/>
           </a:bodyPr>
           <a:lstStyle/>
           <a:p>
-            <a:pPr>
+            <a:pPr algn="l">
               <a:defRPr sz="2800" b="1">
                 <a:solidFill>
                   <a:srgbClr val="272C34"/>
@@ -4540,14 +7442,14 @@
         </p:nvSpPr>
         <p:spPr>
           <a:xfrm>
-            <a:off x="731520" y="1554480"/>
-            <a:ext cx="1188720" cy="128016"/>
+            <a:off x="640080" y="1188720"/>
+            <a:ext cx="1325880" cy="109728"/>
           </a:xfrm>
           <a:prstGeom prst="rect">
             <a:avLst/>
           </a:prstGeom>
           <a:solidFill>
-            <a:srgbClr val="065A82"/>
+            <a:srgbClr val="F96167"/>
           </a:solidFill>
           <a:ln>
             <a:noFill/>
@@ -4583,8 +7485,8 @@
         </p:nvSpPr>
         <p:spPr>
           <a:xfrm>
-            <a:off x="868680" y="1874519"/>
-            <a:ext cx="10332720" cy="3566160"/>
+            <a:off x="10881360" y="384048"/>
+            <a:ext cx="548640" cy="274320"/>
           </a:xfrm>
           <a:prstGeom prst="rect">
             <a:avLst/>
@@ -4592,34 +7494,186 @@
           <a:noFill/>
         </p:spPr>
         <p:txBody>
-          <a:bodyPr wrap="square" lIns="0" rIns="0" tIns="0" bIns="0">
+          <a:bodyPr wrap="square" anchor="t" lIns="0" rIns="0" tIns="0" bIns="0">
             <a:spAutoFit/>
           </a:bodyPr>
           <a:lstStyle/>
           <a:p>
-            <a:pPr algn="l">
-              <a:defRPr sz="1800">
+            <a:pPr algn="r">
+              <a:defRPr sz="1000" b="0">
                 <a:solidFill>
                   <a:srgbClr val="272C34"/>
                 </a:solidFill>
               </a:defRPr>
             </a:pPr>
             <a:r>
-              <a:t>Automated tests cover authentication, catalog operations, engagement rules, recommendations, and analytics. API errors are returned in a structured JSON format with status code discipline.</a:t>
-            </a:r>
-          </a:p>
-        </p:txBody>
-      </p:sp>
-      <p:sp>
-        <p:nvSpPr>
-          <p:cNvPr id="5" name="TextBox 4"/>
+              <a:t>08</a:t>
+            </a:r>
+          </a:p>
+        </p:txBody>
+      </p:sp>
+      <p:sp>
+        <p:nvSpPr>
+          <p:cNvPr id="5" name="Rounded Rectangle 4"/>
+          <p:cNvSpPr/>
+          <p:nvPr/>
+        </p:nvSpPr>
+        <p:spPr>
+          <a:xfrm>
+            <a:off x="868680" y="1783080"/>
+            <a:ext cx="4754880" cy="2011680"/>
+          </a:xfrm>
+          <a:prstGeom prst="roundRect">
+            <a:avLst/>
+          </a:prstGeom>
+          <a:solidFill>
+            <a:srgbClr val="FFFFFF"/>
+          </a:solidFill>
+          <a:ln>
+            <a:solidFill>
+              <a:srgbClr val="FFFFFF"/>
+            </a:solidFill>
+          </a:ln>
+        </p:spPr>
+        <p:style>
+          <a:lnRef idx="1">
+            <a:schemeClr val="accent1"/>
+          </a:lnRef>
+          <a:fillRef idx="3">
+            <a:schemeClr val="accent1"/>
+          </a:fillRef>
+          <a:effectRef idx="2">
+            <a:schemeClr val="accent1"/>
+          </a:effectRef>
+          <a:fontRef idx="minor">
+            <a:schemeClr val="lt1"/>
+          </a:fontRef>
+        </p:style>
+        <p:txBody>
+          <a:bodyPr rtlCol="0" anchor="ctr" wrap="square" lIns="164592" rIns="164592" tIns="128016" bIns="109728"/>
+          <a:lstStyle/>
+          <a:p>
+            <a:pPr algn="ctr">
+              <a:defRPr sz="1600" b="1">
+                <a:solidFill>
+                  <a:srgbClr val="1E2761"/>
+                </a:solidFill>
+              </a:defRPr>
+            </a:pPr>
+            <a:r>
+              <a:t>Automated checks</a:t>
+            </a:r>
+          </a:p>
+          <a:p>
+            <a:pPr>
+              <a:defRPr sz="1200">
+                <a:solidFill>
+                  <a:srgbClr val="272C34"/>
+                </a:solidFill>
+              </a:defRPr>
+            </a:pPr>
+            <a:r>
+              <a:t>Registration and auth</a:t>
+            </a:r>
+            <a:br/>
+            <a:r>
+              <a:t>Catalog list and create</a:t>
+            </a:r>
+            <a:br/>
+            <a:r>
+              <a:t>Bookshelf uniqueness</a:t>
+            </a:r>
+            <a:br/>
+            <a:r>
+              <a:t>Review uniqueness</a:t>
+            </a:r>
+            <a:br/>
+            <a:r>
+              <a:t>Recommendation exclusion</a:t>
+            </a:r>
+            <a:br/>
+            <a:r>
+              <a:t>Analytics responses</a:t>
+            </a:r>
+          </a:p>
+        </p:txBody>
+      </p:sp>
+      <p:sp>
+        <p:nvSpPr>
+          <p:cNvPr id="6" name="Rounded Rectangle 5"/>
+          <p:cNvSpPr/>
+          <p:nvPr/>
+        </p:nvSpPr>
+        <p:spPr>
+          <a:xfrm>
+            <a:off x="5989320" y="1783080"/>
+            <a:ext cx="4663440" cy="2011680"/>
+          </a:xfrm>
+          <a:prstGeom prst="roundRect">
+            <a:avLst/>
+          </a:prstGeom>
+          <a:solidFill>
+            <a:srgbClr val="E7E8D1"/>
+          </a:solidFill>
+          <a:ln>
+            <a:solidFill>
+              <a:srgbClr val="E7E8D1"/>
+            </a:solidFill>
+          </a:ln>
+        </p:spPr>
+        <p:style>
+          <a:lnRef idx="1">
+            <a:schemeClr val="accent1"/>
+          </a:lnRef>
+          <a:fillRef idx="3">
+            <a:schemeClr val="accent1"/>
+          </a:fillRef>
+          <a:effectRef idx="2">
+            <a:schemeClr val="accent1"/>
+          </a:effectRef>
+          <a:fontRef idx="minor">
+            <a:schemeClr val="lt1"/>
+          </a:fontRef>
+        </p:style>
+        <p:txBody>
+          <a:bodyPr rtlCol="0" anchor="ctr" wrap="square" lIns="164592" rIns="164592" tIns="128016" bIns="109728"/>
+          <a:lstStyle/>
+          <a:p>
+            <a:pPr algn="ctr">
+              <a:defRPr sz="1600" b="1">
+                <a:solidFill>
+                  <a:srgbClr val="1E2761"/>
+                </a:solidFill>
+              </a:defRPr>
+            </a:pPr>
+            <a:r>
+              <a:t>Structured errors</a:t>
+            </a:r>
+          </a:p>
+          <a:p>
+            <a:pPr>
+              <a:defRPr sz="1200">
+                <a:solidFill>
+                  <a:srgbClr val="272C34"/>
+                </a:solidFill>
+              </a:defRPr>
+            </a:pPr>
+            <a:r>
+              <a:t>{"error": {"code": "validation_error", "message": "Validation failed.", "details": {"book_id": ["You already have a bookshelf entry for this book."]}}}</a:t>
+            </a:r>
+          </a:p>
+        </p:txBody>
+      </p:sp>
+      <p:sp>
+        <p:nvSpPr>
+          <p:cNvPr id="7" name="TextBox 6"/>
           <p:cNvSpPr txBox="1"/>
           <p:nvPr/>
         </p:nvSpPr>
         <p:spPr>
           <a:xfrm>
-            <a:off x="9966960" y="6217920"/>
-            <a:ext cx="1005840" cy="274320"/>
+            <a:off x="868680" y="4251960"/>
+            <a:ext cx="10058400" cy="914400"/>
           </a:xfrm>
           <a:prstGeom prst="rect">
             <a:avLst/>
@@ -4627,20 +7681,20 @@
           <a:noFill/>
         </p:spPr>
         <p:txBody>
-          <a:bodyPr wrap="none">
+          <a:bodyPr wrap="square" anchor="t" lIns="0" rIns="0" tIns="0" bIns="0">
             <a:spAutoFit/>
           </a:bodyPr>
           <a:lstStyle/>
           <a:p>
-            <a:pPr algn="r">
-              <a:defRPr sz="1000">
+            <a:pPr algn="l">
+              <a:defRPr sz="1800" b="0">
                 <a:solidFill>
                   <a:srgbClr val="272C34"/>
                 </a:solidFill>
               </a:defRPr>
             </a:pPr>
             <a:r>
-              <a:t>08</a:t>
+              <a:t>The API enforces serializer validation, model constraints, permission checks, and consistent HTTP status handling.</a:t>
             </a:r>
           </a:p>
         </p:txBody>
@@ -4659,7 +7713,7 @@
     <p:bg>
       <p:bgPr>
         <a:solidFill>
-          <a:srgbClr val="F5F6F0"/>
+          <a:srgbClr val="F7F4EA"/>
         </a:solidFill>
         <a:effectLst/>
       </p:bgPr>
@@ -4679,8 +7733,8 @@
         </p:nvSpPr>
         <p:spPr>
           <a:xfrm>
-            <a:off x="731520" y="548640"/>
-            <a:ext cx="10607040" cy="822960"/>
+            <a:off x="640080" y="411480"/>
+            <a:ext cx="8412480" cy="640080"/>
           </a:xfrm>
           <a:prstGeom prst="rect">
             <a:avLst/>
@@ -4688,12 +7742,12 @@
           <a:noFill/>
         </p:spPr>
         <p:txBody>
-          <a:bodyPr wrap="square">
+          <a:bodyPr wrap="square" anchor="t" lIns="0" rIns="0" tIns="0" bIns="0">
             <a:spAutoFit/>
           </a:bodyPr>
           <a:lstStyle/>
           <a:p>
-            <a:pPr>
+            <a:pPr algn="l">
               <a:defRPr sz="2800" b="1">
                 <a:solidFill>
                   <a:srgbClr val="272C34"/>
@@ -4701,7 +7755,7 @@
               </a:defRPr>
             </a:pPr>
             <a:r>
-              <a:t>Version Control and Deliverables</a:t>
+              <a:t>Version Control Practice</a:t>
             </a:r>
           </a:p>
         </p:txBody>
@@ -4714,14 +7768,14 @@
         </p:nvSpPr>
         <p:spPr>
           <a:xfrm>
-            <a:off x="731520" y="1554480"/>
-            <a:ext cx="1188720" cy="128016"/>
+            <a:off x="640080" y="1188720"/>
+            <a:ext cx="1325880" cy="109728"/>
           </a:xfrm>
           <a:prstGeom prst="rect">
             <a:avLst/>
           </a:prstGeom>
           <a:solidFill>
-            <a:srgbClr val="F96167"/>
+            <a:srgbClr val="065A82"/>
           </a:solidFill>
           <a:ln>
             <a:noFill/>
@@ -4757,8 +7811,8 @@
         </p:nvSpPr>
         <p:spPr>
           <a:xfrm>
-            <a:off x="868680" y="1874519"/>
-            <a:ext cx="10332720" cy="3566160"/>
+            <a:off x="10881360" y="384048"/>
+            <a:ext cx="548640" cy="274320"/>
           </a:xfrm>
           <a:prstGeom prst="rect">
             <a:avLst/>
@@ -4766,34 +7820,364 @@
           <a:noFill/>
         </p:spPr>
         <p:txBody>
-          <a:bodyPr wrap="square" lIns="0" rIns="0" tIns="0" bIns="0">
+          <a:bodyPr wrap="square" anchor="t" lIns="0" rIns="0" tIns="0" bIns="0">
             <a:spAutoFit/>
           </a:bodyPr>
           <a:lstStyle/>
           <a:p>
-            <a:pPr algn="l">
-              <a:defRPr sz="1800">
+            <a:pPr algn="r">
+              <a:defRPr sz="1000" b="0">
                 <a:solidFill>
                   <a:srgbClr val="272C34"/>
                 </a:solidFill>
               </a:defRPr>
             </a:pPr>
             <a:r>
-              <a:t>The final submission includes a public repository, README, API documentation, technical report, slides, and a declared GenAI appendix. Commit history is organized by feature groups rather than by a single final dump.</a:t>
-            </a:r>
-          </a:p>
-        </p:txBody>
-      </p:sp>
-      <p:sp>
-        <p:nvSpPr>
-          <p:cNvPr id="5" name="TextBox 4"/>
+              <a:t>09</a:t>
+            </a:r>
+          </a:p>
+        </p:txBody>
+      </p:sp>
+      <p:sp>
+        <p:nvSpPr>
+          <p:cNvPr id="5" name="Rounded Rectangle 4"/>
+          <p:cNvSpPr/>
+          <p:nvPr/>
+        </p:nvSpPr>
+        <p:spPr>
+          <a:xfrm>
+            <a:off x="1051560" y="1691640"/>
+            <a:ext cx="9326880" cy="530352"/>
+          </a:xfrm>
+          <a:prstGeom prst="roundRect">
+            <a:avLst/>
+          </a:prstGeom>
+          <a:solidFill>
+            <a:srgbClr val="FFFFFF"/>
+          </a:solidFill>
+          <a:ln>
+            <a:solidFill>
+              <a:srgbClr val="FFFFFF"/>
+            </a:solidFill>
+          </a:ln>
+        </p:spPr>
+        <p:style>
+          <a:lnRef idx="1">
+            <a:schemeClr val="accent1"/>
+          </a:lnRef>
+          <a:fillRef idx="3">
+            <a:schemeClr val="accent1"/>
+          </a:fillRef>
+          <a:effectRef idx="2">
+            <a:schemeClr val="accent1"/>
+          </a:effectRef>
+          <a:fontRef idx="minor">
+            <a:schemeClr val="lt1"/>
+          </a:fontRef>
+        </p:style>
+        <p:txBody>
+          <a:bodyPr rtlCol="0" anchor="ctr" wrap="square" lIns="164592" rIns="164592" tIns="128016" bIns="109728"/>
+          <a:lstStyle/>
+          <a:p>
+            <a:pPr algn="ctr">
+              <a:defRPr sz="1600" b="1">
+                <a:solidFill>
+                  <a:srgbClr val="1E2761"/>
+                </a:solidFill>
+              </a:defRPr>
+            </a:pPr>
+            <a:r>
+              <a:t>Commit 1</a:t>
+            </a:r>
+          </a:p>
+          <a:p>
+            <a:pPr>
+              <a:defRPr sz="1200">
+                <a:solidFill>
+                  <a:srgbClr val="272C34"/>
+                </a:solidFill>
+              </a:defRPr>
+            </a:pPr>
+            <a:r>
+              <a:t>Runtime setup and API modules</a:t>
+            </a:r>
+          </a:p>
+        </p:txBody>
+      </p:sp>
+      <p:sp>
+        <p:nvSpPr>
+          <p:cNvPr id="6" name="Rounded Rectangle 5"/>
+          <p:cNvSpPr/>
+          <p:nvPr/>
+        </p:nvSpPr>
+        <p:spPr>
+          <a:xfrm>
+            <a:off x="1051560" y="2423160"/>
+            <a:ext cx="9326880" cy="530352"/>
+          </a:xfrm>
+          <a:prstGeom prst="roundRect">
+            <a:avLst/>
+          </a:prstGeom>
+          <a:solidFill>
+            <a:srgbClr val="E7E8D1"/>
+          </a:solidFill>
+          <a:ln>
+            <a:solidFill>
+              <a:srgbClr val="E7E8D1"/>
+            </a:solidFill>
+          </a:ln>
+        </p:spPr>
+        <p:style>
+          <a:lnRef idx="1">
+            <a:schemeClr val="accent1"/>
+          </a:lnRef>
+          <a:fillRef idx="3">
+            <a:schemeClr val="accent1"/>
+          </a:fillRef>
+          <a:effectRef idx="2">
+            <a:schemeClr val="accent1"/>
+          </a:effectRef>
+          <a:fontRef idx="minor">
+            <a:schemeClr val="lt1"/>
+          </a:fontRef>
+        </p:style>
+        <p:txBody>
+          <a:bodyPr rtlCol="0" anchor="ctr" wrap="square" lIns="164592" rIns="164592" tIns="128016" bIns="109728"/>
+          <a:lstStyle/>
+          <a:p>
+            <a:pPr algn="ctr">
+              <a:defRPr sz="1600" b="1">
+                <a:solidFill>
+                  <a:srgbClr val="1E2761"/>
+                </a:solidFill>
+              </a:defRPr>
+            </a:pPr>
+            <a:r>
+              <a:t>Commit 2</a:t>
+            </a:r>
+          </a:p>
+          <a:p>
+            <a:pPr>
+              <a:defRPr sz="1200">
+                <a:solidFill>
+                  <a:srgbClr val="272C34"/>
+                </a:solidFill>
+              </a:defRPr>
+            </a:pPr>
+            <a:r>
+              <a:t>Google Books sample and seed data</a:t>
+            </a:r>
+          </a:p>
+        </p:txBody>
+      </p:sp>
+      <p:sp>
+        <p:nvSpPr>
+          <p:cNvPr id="7" name="Rounded Rectangle 6"/>
+          <p:cNvSpPr/>
+          <p:nvPr/>
+        </p:nvSpPr>
+        <p:spPr>
+          <a:xfrm>
+            <a:off x="1051560" y="3154680"/>
+            <a:ext cx="9326880" cy="530352"/>
+          </a:xfrm>
+          <a:prstGeom prst="roundRect">
+            <a:avLst/>
+          </a:prstGeom>
+          <a:solidFill>
+            <a:srgbClr val="FFFFFF"/>
+          </a:solidFill>
+          <a:ln>
+            <a:solidFill>
+              <a:srgbClr val="FFFFFF"/>
+            </a:solidFill>
+          </a:ln>
+        </p:spPr>
+        <p:style>
+          <a:lnRef idx="1">
+            <a:schemeClr val="accent1"/>
+          </a:lnRef>
+          <a:fillRef idx="3">
+            <a:schemeClr val="accent1"/>
+          </a:fillRef>
+          <a:effectRef idx="2">
+            <a:schemeClr val="accent1"/>
+          </a:effectRef>
+          <a:fontRef idx="minor">
+            <a:schemeClr val="lt1"/>
+          </a:fontRef>
+        </p:style>
+        <p:txBody>
+          <a:bodyPr rtlCol="0" anchor="ctr" wrap="square" lIns="164592" rIns="164592" tIns="128016" bIns="109728"/>
+          <a:lstStyle/>
+          <a:p>
+            <a:pPr algn="ctr">
+              <a:defRPr sz="1600" b="1">
+                <a:solidFill>
+                  <a:srgbClr val="1E2761"/>
+                </a:solidFill>
+              </a:defRPr>
+            </a:pPr>
+            <a:r>
+              <a:t>Commit 3</a:t>
+            </a:r>
+          </a:p>
+          <a:p>
+            <a:pPr>
+              <a:defRPr sz="1200">
+                <a:solidFill>
+                  <a:srgbClr val="272C34"/>
+                </a:solidFill>
+              </a:defRPr>
+            </a:pPr>
+            <a:r>
+              <a:t>Automated tests</a:t>
+            </a:r>
+          </a:p>
+        </p:txBody>
+      </p:sp>
+      <p:sp>
+        <p:nvSpPr>
+          <p:cNvPr id="8" name="Rounded Rectangle 7"/>
+          <p:cNvSpPr/>
+          <p:nvPr/>
+        </p:nvSpPr>
+        <p:spPr>
+          <a:xfrm>
+            <a:off x="1051560" y="3886200"/>
+            <a:ext cx="9326880" cy="530352"/>
+          </a:xfrm>
+          <a:prstGeom prst="roundRect">
+            <a:avLst/>
+          </a:prstGeom>
+          <a:solidFill>
+            <a:srgbClr val="E7E8D1"/>
+          </a:solidFill>
+          <a:ln>
+            <a:solidFill>
+              <a:srgbClr val="E7E8D1"/>
+            </a:solidFill>
+          </a:ln>
+        </p:spPr>
+        <p:style>
+          <a:lnRef idx="1">
+            <a:schemeClr val="accent1"/>
+          </a:lnRef>
+          <a:fillRef idx="3">
+            <a:schemeClr val="accent1"/>
+          </a:fillRef>
+          <a:effectRef idx="2">
+            <a:schemeClr val="accent1"/>
+          </a:effectRef>
+          <a:fontRef idx="minor">
+            <a:schemeClr val="lt1"/>
+          </a:fontRef>
+        </p:style>
+        <p:txBody>
+          <a:bodyPr rtlCol="0" anchor="ctr" wrap="square" lIns="164592" rIns="164592" tIns="128016" bIns="109728"/>
+          <a:lstStyle/>
+          <a:p>
+            <a:pPr algn="ctr">
+              <a:defRPr sz="1600" b="1">
+                <a:solidFill>
+                  <a:srgbClr val="1E2761"/>
+                </a:solidFill>
+              </a:defRPr>
+            </a:pPr>
+            <a:r>
+              <a:t>Commit 4</a:t>
+            </a:r>
+          </a:p>
+          <a:p>
+            <a:pPr>
+              <a:defRPr sz="1200">
+                <a:solidFill>
+                  <a:srgbClr val="272C34"/>
+                </a:solidFill>
+              </a:defRPr>
+            </a:pPr>
+            <a:r>
+              <a:t>Source documentation and asset builders</a:t>
+            </a:r>
+          </a:p>
+        </p:txBody>
+      </p:sp>
+      <p:sp>
+        <p:nvSpPr>
+          <p:cNvPr id="9" name="Rounded Rectangle 8"/>
+          <p:cNvSpPr/>
+          <p:nvPr/>
+        </p:nvSpPr>
+        <p:spPr>
+          <a:xfrm>
+            <a:off x="1051560" y="4617720"/>
+            <a:ext cx="9326880" cy="530352"/>
+          </a:xfrm>
+          <a:prstGeom prst="roundRect">
+            <a:avLst/>
+          </a:prstGeom>
+          <a:solidFill>
+            <a:srgbClr val="FFFFFF"/>
+          </a:solidFill>
+          <a:ln>
+            <a:solidFill>
+              <a:srgbClr val="FFFFFF"/>
+            </a:solidFill>
+          </a:ln>
+        </p:spPr>
+        <p:style>
+          <a:lnRef idx="1">
+            <a:schemeClr val="accent1"/>
+          </a:lnRef>
+          <a:fillRef idx="3">
+            <a:schemeClr val="accent1"/>
+          </a:fillRef>
+          <a:effectRef idx="2">
+            <a:schemeClr val="accent1"/>
+          </a:effectRef>
+          <a:fontRef idx="minor">
+            <a:schemeClr val="lt1"/>
+          </a:fontRef>
+        </p:style>
+        <p:txBody>
+          <a:bodyPr rtlCol="0" anchor="ctr" wrap="square" lIns="164592" rIns="164592" tIns="128016" bIns="109728"/>
+          <a:lstStyle/>
+          <a:p>
+            <a:pPr algn="ctr">
+              <a:defRPr sz="1600" b="1">
+                <a:solidFill>
+                  <a:srgbClr val="1E2761"/>
+                </a:solidFill>
+              </a:defRPr>
+            </a:pPr>
+            <a:r>
+              <a:t>Commit 5</a:t>
+            </a:r>
+          </a:p>
+          <a:p>
+            <a:pPr>
+              <a:defRPr sz="1200">
+                <a:solidFill>
+                  <a:srgbClr val="272C34"/>
+                </a:solidFill>
+              </a:defRPr>
+            </a:pPr>
+            <a:r>
+              <a:t>Generated PDFs, schema, and presentation deck</a:t>
+            </a:r>
+          </a:p>
+        </p:txBody>
+      </p:sp>
+      <p:sp>
+        <p:nvSpPr>
+          <p:cNvPr id="10" name="TextBox 9"/>
           <p:cNvSpPr txBox="1"/>
           <p:nvPr/>
         </p:nvSpPr>
         <p:spPr>
           <a:xfrm>
-            <a:off x="9966960" y="6217920"/>
-            <a:ext cx="1005840" cy="274320"/>
+            <a:off x="1051560" y="5669280"/>
+            <a:ext cx="9509760" cy="411480"/>
           </a:xfrm>
           <a:prstGeom prst="rect">
             <a:avLst/>
@@ -4801,20 +8185,20 @@
           <a:noFill/>
         </p:spPr>
         <p:txBody>
-          <a:bodyPr wrap="none">
+          <a:bodyPr wrap="square" anchor="t" lIns="0" rIns="0" tIns="0" bIns="0">
             <a:spAutoFit/>
           </a:bodyPr>
           <a:lstStyle/>
           <a:p>
-            <a:pPr algn="r">
-              <a:defRPr sz="1000">
+            <a:pPr algn="l">
+              <a:defRPr sz="1600" b="0">
                 <a:solidFill>
                   <a:srgbClr val="272C34"/>
                 </a:solidFill>
               </a:defRPr>
             </a:pPr>
             <a:r>
-              <a:t>09</a:t>
+              <a:t>The public repository shows staged delivery instead of a single final dump.</a:t>
             </a:r>
           </a:p>
         </p:txBody>

</xml_diff>

<commit_message>
docs: switch deployment package to PythonAnywhere
</commit_message>
<xml_diff>
--- a/slides/bookscope_presentation.pptx
+++ b/slides/bookscope_presentation.pptx
@@ -3425,7 +3425,7 @@
               </a:defRPr>
             </a:pPr>
             <a:r>
-              <a:t>Deliverables and Deployment</a:t>
+              <a:t>Deliverables and PythonAnywhere Deployment</a:t>
             </a:r>
           </a:p>
         </p:txBody>
@@ -3713,7 +3713,7 @@
               </a:defRPr>
             </a:pPr>
             <a:r>
-              <a:t>Deployment package</a:t>
+              <a:t>Deployment method</a:t>
             </a:r>
           </a:p>
           <a:p>
@@ -3725,19 +3725,19 @@
               </a:defRPr>
             </a:pPr>
             <a:r>
-              <a:t>Procfile</a:t>
+              <a:t>Manual web app</a:t>
             </a:r>
             <a:br/>
             <a:r>
-              <a:t>render.yaml</a:t>
+              <a:t>Virtualenv</a:t>
             </a:r>
             <a:br/>
             <a:r>
-              <a:t>gunicorn</a:t>
+              <a:t>Platform WSGI file</a:t>
             </a:r>
             <a:br/>
             <a:r>
-              <a:t>Env-driven hosts and secrets</a:t>
+              <a:t>Static mappings</a:t>
             </a:r>
           </a:p>
         </p:txBody>
@@ -3803,7 +3803,7 @@
               </a:defRPr>
             </a:pPr>
             <a:r>
-              <a:t>Provisioning needs a real hosting account. This repo is prepared for that step.</a:t>
+              <a:t>Final publication still needs a PythonAnywhere account and reload step.</a:t>
             </a:r>
           </a:p>
         </p:txBody>
@@ -3838,7 +3838,7 @@
               </a:defRPr>
             </a:pPr>
             <a:r>
-              <a:t>Repository URL: github.com/IJF9GAWHY8FGA8/bookscope-api</a:t>
+              <a:t>Target URL: https://YOUR_PYTHONANYWHERE_USERNAME.pythonanywhere.com/</a:t>
             </a:r>
           </a:p>
         </p:txBody>
@@ -4681,7 +4681,7 @@
               </a:defRPr>
             </a:pPr>
             <a:r>
-              <a:t>Limitations: SQLite scale, heuristic ranking, hosting still requires external platform provisioning</a:t>
+              <a:t>Limitations: SQLite scale, heuristic ranking, and a final PythonAnywhere account-side publish step</a:t>
             </a:r>
           </a:p>
           <a:p>

</xml_diff>

<commit_message>
docs: record live PythonAnywhere deployment and refresh submission assets
</commit_message>
<xml_diff>
--- a/slides/bookscope_presentation.pptx
+++ b/slides/bookscope_presentation.pptx
@@ -3803,7 +3803,7 @@
               </a:defRPr>
             </a:pPr>
             <a:r>
-              <a:t>Final publication still needs a PythonAnywhere account and reload step.</a:t>
+              <a:t>Live deployment verified on PythonAnywhere with health, docs, auth, and API smoke checks.</a:t>
             </a:r>
           </a:p>
         </p:txBody>
@@ -3838,7 +3838,7 @@
               </a:defRPr>
             </a:pPr>
             <a:r>
-              <a:t>Target URL: https://YOUR_PYTHONANYWHERE_USERNAME.pythonanywhere.com/</a:t>
+              <a:t>Live URL: https://pw123.pythonanywhere.com/</a:t>
             </a:r>
           </a:p>
         </p:txBody>
@@ -4681,7 +4681,7 @@
               </a:defRPr>
             </a:pPr>
             <a:r>
-              <a:t>Limitations: SQLite scale, heuristic ranking, and a final PythonAnywhere account-side publish step</a:t>
+              <a:t>Limitations: SQLite scale, heuristic ranking, and manual PythonAnywhere dashboard-side operations</a:t>
             </a:r>
           </a:p>
           <a:p>

</xml_diff>